<commit_message>
Harden Holt release and public launch
Signed-off-by: Raed <Raed2180416@users.noreply.github.com>
</commit_message>
<xml_diff>
--- a/docs/pitch/Holt-Preseed-Deck-2026-08-11.pptx
+++ b/docs/pitch/Holt-Preseed-Deck-2026-08-11.pptx
@@ -2,25 +2,25 @@
 <file path=ppt/presentation.xml><?xml version="1.0" encoding="utf-8"?>
 <p:presentation xmlns:p="http://schemas.openxmlformats.org/presentationml/2006/main">
   <p:sldMasterIdLst>
-    <p:sldMasterId xmlns:r="http://schemas.openxmlformats.org/officeDocument/2006/relationships" id="2147483648" r:id="R1b8dcab387c64b75"/>
+    <p:sldMasterId xmlns:r="http://schemas.openxmlformats.org/officeDocument/2006/relationships" id="2147483648" r:id="R25d6116e5bd94cde"/>
   </p:sldMasterIdLst>
   <p:notesMasterIdLst>
-    <p:notesMasterId xmlns:r="http://schemas.openxmlformats.org/officeDocument/2006/relationships" r:id="R17221fc9b6774a42"/>
+    <p:notesMasterId xmlns:r="http://schemas.openxmlformats.org/officeDocument/2006/relationships" r:id="Rd16c0332c5e84bf0"/>
   </p:notesMasterIdLst>
   <p:sldIdLst>
-    <p:sldId xmlns:r="http://schemas.openxmlformats.org/officeDocument/2006/relationships" id="256" r:id="Rf3552ff785684619"/>
-    <p:sldId xmlns:r="http://schemas.openxmlformats.org/officeDocument/2006/relationships" id="257" r:id="Raf8f7bb2d1194107"/>
-    <p:sldId xmlns:r="http://schemas.openxmlformats.org/officeDocument/2006/relationships" id="258" r:id="R0030bfdb81c64f5e"/>
-    <p:sldId xmlns:r="http://schemas.openxmlformats.org/officeDocument/2006/relationships" id="259" r:id="R9f32447be1804f39"/>
-    <p:sldId xmlns:r="http://schemas.openxmlformats.org/officeDocument/2006/relationships" id="260" r:id="Rdb68bcba4ebe4b86"/>
-    <p:sldId xmlns:r="http://schemas.openxmlformats.org/officeDocument/2006/relationships" id="261" r:id="R0cef099784b04857"/>
-    <p:sldId xmlns:r="http://schemas.openxmlformats.org/officeDocument/2006/relationships" id="262" r:id="Rf3671780cd904ca0"/>
-    <p:sldId xmlns:r="http://schemas.openxmlformats.org/officeDocument/2006/relationships" id="263" r:id="R4a914967671b4dac"/>
-    <p:sldId xmlns:r="http://schemas.openxmlformats.org/officeDocument/2006/relationships" id="264" r:id="R0a00c9de481f4537"/>
-    <p:sldId xmlns:r="http://schemas.openxmlformats.org/officeDocument/2006/relationships" id="265" r:id="Rc355cb24ca3c4427"/>
-    <p:sldId xmlns:r="http://schemas.openxmlformats.org/officeDocument/2006/relationships" id="266" r:id="R1cb6481f92d84e35"/>
-    <p:sldId xmlns:r="http://schemas.openxmlformats.org/officeDocument/2006/relationships" id="267" r:id="Racf90c33117c4efe"/>
-    <p:sldId xmlns:r="http://schemas.openxmlformats.org/officeDocument/2006/relationships" id="268" r:id="R70eaf1f64aca4b91"/>
+    <p:sldId xmlns:r="http://schemas.openxmlformats.org/officeDocument/2006/relationships" id="256" r:id="R425a087f5fec4854"/>
+    <p:sldId xmlns:r="http://schemas.openxmlformats.org/officeDocument/2006/relationships" id="257" r:id="Raf1c99491afa45c9"/>
+    <p:sldId xmlns:r="http://schemas.openxmlformats.org/officeDocument/2006/relationships" id="258" r:id="Re1f464887ed54e91"/>
+    <p:sldId xmlns:r="http://schemas.openxmlformats.org/officeDocument/2006/relationships" id="259" r:id="R8346ceb746cc4fc5"/>
+    <p:sldId xmlns:r="http://schemas.openxmlformats.org/officeDocument/2006/relationships" id="260" r:id="Rb95a905abe4a4e32"/>
+    <p:sldId xmlns:r="http://schemas.openxmlformats.org/officeDocument/2006/relationships" id="261" r:id="R64fab0fec20d4815"/>
+    <p:sldId xmlns:r="http://schemas.openxmlformats.org/officeDocument/2006/relationships" id="262" r:id="Rc12f5c4a342a4926"/>
+    <p:sldId xmlns:r="http://schemas.openxmlformats.org/officeDocument/2006/relationships" id="263" r:id="Rdf2ad6d0064c4094"/>
+    <p:sldId xmlns:r="http://schemas.openxmlformats.org/officeDocument/2006/relationships" id="264" r:id="R02a5ea011d1f457d"/>
+    <p:sldId xmlns:r="http://schemas.openxmlformats.org/officeDocument/2006/relationships" id="265" r:id="Re51d4c3e190d4344"/>
+    <p:sldId xmlns:r="http://schemas.openxmlformats.org/officeDocument/2006/relationships" id="266" r:id="Rf1a7bd983b334378"/>
+    <p:sldId xmlns:r="http://schemas.openxmlformats.org/officeDocument/2006/relationships" id="267" r:id="R57acd67d080f4e64"/>
+    <p:sldId xmlns:r="http://schemas.openxmlformats.org/officeDocument/2006/relationships" id="268" r:id="R73240c65616a4d80"/>
   </p:sldIdLst>
   <p:sldSz cx="12192000" cy="6858000"/>
   <p:notesSz cx="6858000" cy="9144000"/>
@@ -1672,7 +1672,7 @@
   </p:cSld>
   <p:clrMap bg1="lt1" tx1="dk1" bg2="lt2" tx2="dk2" accent1="accent1" accent2="accent2" accent3="accent3" accent4="accent4" accent5="accent5" accent6="accent6" hlink="hlink" folHlink="folHlink"/>
   <p:sldLayoutIdLst>
-    <p:sldLayoutId xmlns:r="http://schemas.openxmlformats.org/officeDocument/2006/relationships" id="2147483649" r:id="Rf301635d77a44554"/>
+    <p:sldLayoutId xmlns:r="http://schemas.openxmlformats.org/officeDocument/2006/relationships" id="2147483649" r:id="Rd97a76c745664798"/>
   </p:sldLayoutIdLst>
   <p:txStyles>
     <p:titleStyle>
@@ -2223,7 +2223,7 @@
           <p:cNvPr id="6" name="">
             <a:extLst xmlns:a="http://schemas.openxmlformats.org/drawingml/2006/main">
               <a:ext uri="{FF2B5EF4-FFF2-40B4-BE49-F238E27FC236}">
-                <a16:creationId xmlns:a16="http://schemas.microsoft.com/office/drawing/2014/main" id="{6C7BAE70-7503-4858-A0EB-B4F4C9393A11}"/>
+                <a16:creationId xmlns:a16="http://schemas.microsoft.com/office/drawing/2014/main" id="{2D20930C-5927-411F-94BE-37334A43EC0D}"/>
               </a:ext>
             </a:extLst>
           </p:cNvPr>
@@ -2281,7 +2281,7 @@
           <p:cNvPr id="2" name="">
             <a:extLst xmlns:a="http://schemas.openxmlformats.org/drawingml/2006/main">
               <a:ext uri="{FF2B5EF4-FFF2-40B4-BE49-F238E27FC236}">
-                <a16:creationId xmlns:a16="http://schemas.microsoft.com/office/drawing/2014/main" id="{EBDAC9C6-636F-453A-8217-4893CAE6021C}"/>
+                <a16:creationId xmlns:a16="http://schemas.microsoft.com/office/drawing/2014/main" id="{5ACCAFA9-5720-4C78-9F39-CC5EB793344A}"/>
               </a:ext>
             </a:extLst>
           </p:cNvPr>
@@ -2362,7 +2362,7 @@
           <p:cNvPr id="3" name="">
             <a:extLst xmlns:a="http://schemas.openxmlformats.org/drawingml/2006/main">
               <a:ext uri="{FF2B5EF4-FFF2-40B4-BE49-F238E27FC236}">
-                <a16:creationId xmlns:a16="http://schemas.microsoft.com/office/drawing/2014/main" id="{57ABCD38-59C0-46A9-92BB-17645F5A70A1}"/>
+                <a16:creationId xmlns:a16="http://schemas.microsoft.com/office/drawing/2014/main" id="{3F7B27D2-EEC2-45E5-B697-B5EB53C53544}"/>
               </a:ext>
             </a:extLst>
           </p:cNvPr>
@@ -2420,7 +2420,7 @@
           <p:cNvPr id="4" name="">
             <a:extLst xmlns:a="http://schemas.openxmlformats.org/drawingml/2006/main">
               <a:ext uri="{FF2B5EF4-FFF2-40B4-BE49-F238E27FC236}">
-                <a16:creationId xmlns:a16="http://schemas.microsoft.com/office/drawing/2014/main" id="{4A7D398E-3328-4618-9A54-3F7EC4CF6D3C}"/>
+                <a16:creationId xmlns:a16="http://schemas.microsoft.com/office/drawing/2014/main" id="{143E44F8-B5CE-4524-96A0-F5F2C4D31B57}"/>
               </a:ext>
             </a:extLst>
           </p:cNvPr>
@@ -2451,7 +2451,7 @@
           <p:cNvPr id="5" name="">
             <a:extLst xmlns:a="http://schemas.openxmlformats.org/drawingml/2006/main">
               <a:ext uri="{FF2B5EF4-FFF2-40B4-BE49-F238E27FC236}">
-                <a16:creationId xmlns:a16="http://schemas.microsoft.com/office/drawing/2014/main" id="{732A108D-F4B6-4CDE-BEB0-137A95505750}"/>
+                <a16:creationId xmlns:a16="http://schemas.microsoft.com/office/drawing/2014/main" id="{F935246D-FA1A-402E-96C9-B4360AC83A9A}"/>
               </a:ext>
             </a:extLst>
           </p:cNvPr>
@@ -2530,7 +2530,7 @@
     </p:spTree>
     <p:extLst>
       <p:ext uri="{BB962C8B-B14F-4D97-AF65-F5344CB8AC3E}">
-        <p14:creationId xmlns:p14="http://schemas.microsoft.com/office/powerpoint/2010/main" val="1117843243"/>
+        <p14:creationId xmlns:p14="http://schemas.microsoft.com/office/powerpoint/2010/main" val="407328331"/>
       </p:ext>
     </p:extLst>
   </p:cSld>
@@ -2561,7 +2561,7 @@
           <p:cNvPr id="21" name="">
             <a:extLst xmlns:a="http://schemas.openxmlformats.org/drawingml/2006/main">
               <a:ext uri="{FF2B5EF4-FFF2-40B4-BE49-F238E27FC236}">
-                <a16:creationId xmlns:a16="http://schemas.microsoft.com/office/drawing/2014/main" id="{325B3014-2512-49B7-BA7C-DC8EEC4EC934}"/>
+                <a16:creationId xmlns:a16="http://schemas.microsoft.com/office/drawing/2014/main" id="{A7B3276D-D07A-48EC-BECE-E2AE325AF7F5}"/>
               </a:ext>
             </a:extLst>
           </p:cNvPr>
@@ -2619,7 +2619,7 @@
           <p:cNvPr id="2" name="">
             <a:extLst xmlns:a="http://schemas.openxmlformats.org/drawingml/2006/main">
               <a:ext uri="{FF2B5EF4-FFF2-40B4-BE49-F238E27FC236}">
-                <a16:creationId xmlns:a16="http://schemas.microsoft.com/office/drawing/2014/main" id="{6BB6123C-E44D-4FB9-B4A5-DC9ECE742B6C}"/>
+                <a16:creationId xmlns:a16="http://schemas.microsoft.com/office/drawing/2014/main" id="{9D273E11-0F27-4EF9-AA6E-602266B06703}"/>
               </a:ext>
             </a:extLst>
           </p:cNvPr>
@@ -2677,7 +2677,7 @@
           <p:cNvPr id="3" name="">
             <a:extLst xmlns:a="http://schemas.openxmlformats.org/drawingml/2006/main">
               <a:ext uri="{FF2B5EF4-FFF2-40B4-BE49-F238E27FC236}">
-                <a16:creationId xmlns:a16="http://schemas.microsoft.com/office/drawing/2014/main" id="{ABB2E100-620B-4492-900B-7656BC6F9B7A}"/>
+                <a16:creationId xmlns:a16="http://schemas.microsoft.com/office/drawing/2014/main" id="{49AA6DF5-CAE5-4FBE-BDFF-89A3DB8D2EFC}"/>
               </a:ext>
             </a:extLst>
           </p:cNvPr>
@@ -2708,7 +2708,7 @@
           <p:cNvPr id="4" name="">
             <a:extLst xmlns:a="http://schemas.openxmlformats.org/drawingml/2006/main">
               <a:ext uri="{FF2B5EF4-FFF2-40B4-BE49-F238E27FC236}">
-                <a16:creationId xmlns:a16="http://schemas.microsoft.com/office/drawing/2014/main" id="{0B413636-8554-4663-8862-6DB27A8559FD}"/>
+                <a16:creationId xmlns:a16="http://schemas.microsoft.com/office/drawing/2014/main" id="{9FD13A15-4F53-49B5-BD21-A54FBC38550A}"/>
               </a:ext>
             </a:extLst>
           </p:cNvPr>
@@ -2766,7 +2766,7 @@
           <p:cNvPr id="5" name="">
             <a:extLst xmlns:a="http://schemas.openxmlformats.org/drawingml/2006/main">
               <a:ext uri="{FF2B5EF4-FFF2-40B4-BE49-F238E27FC236}">
-                <a16:creationId xmlns:a16="http://schemas.microsoft.com/office/drawing/2014/main" id="{2152C0EA-3915-44AB-B9B3-BBDB5DFEE88D}"/>
+                <a16:creationId xmlns:a16="http://schemas.microsoft.com/office/drawing/2014/main" id="{DE3F2326-2E42-4C04-B5D6-755D43A48FA4}"/>
               </a:ext>
             </a:extLst>
           </p:cNvPr>
@@ -2824,7 +2824,7 @@
           <p:cNvPr id="6" name="">
             <a:extLst xmlns:a="http://schemas.openxmlformats.org/drawingml/2006/main">
               <a:ext uri="{FF2B5EF4-FFF2-40B4-BE49-F238E27FC236}">
-                <a16:creationId xmlns:a16="http://schemas.microsoft.com/office/drawing/2014/main" id="{3C1FB0A4-227E-4C6D-815F-D7608979EA5B}"/>
+                <a16:creationId xmlns:a16="http://schemas.microsoft.com/office/drawing/2014/main" id="{6E3841A4-BB72-4B6F-83E1-A76E62D8BFB0}"/>
               </a:ext>
             </a:extLst>
           </p:cNvPr>
@@ -2882,7 +2882,7 @@
           <p:cNvPr id="7" name="">
             <a:extLst xmlns:a="http://schemas.openxmlformats.org/drawingml/2006/main">
               <a:ext uri="{FF2B5EF4-FFF2-40B4-BE49-F238E27FC236}">
-                <a16:creationId xmlns:a16="http://schemas.microsoft.com/office/drawing/2014/main" id="{383E14D1-5503-4EF4-8247-CE2A40F5E3DE}"/>
+                <a16:creationId xmlns:a16="http://schemas.microsoft.com/office/drawing/2014/main" id="{6AD87532-EE98-46CE-89FB-238F95E3B3DF}"/>
               </a:ext>
             </a:extLst>
           </p:cNvPr>
@@ -2940,7 +2940,7 @@
           <p:cNvPr id="8" name="">
             <a:extLst xmlns:a="http://schemas.openxmlformats.org/drawingml/2006/main">
               <a:ext uri="{FF2B5EF4-FFF2-40B4-BE49-F238E27FC236}">
-                <a16:creationId xmlns:a16="http://schemas.microsoft.com/office/drawing/2014/main" id="{7A71435D-1BB3-44A3-BF68-512725C42595}"/>
+                <a16:creationId xmlns:a16="http://schemas.microsoft.com/office/drawing/2014/main" id="{7C0A511B-21ED-4C68-A281-C198CC0368F9}"/>
               </a:ext>
             </a:extLst>
           </p:cNvPr>
@@ -2998,7 +2998,7 @@
           <p:cNvPr id="9" name="">
             <a:extLst xmlns:a="http://schemas.openxmlformats.org/drawingml/2006/main">
               <a:ext uri="{FF2B5EF4-FFF2-40B4-BE49-F238E27FC236}">
-                <a16:creationId xmlns:a16="http://schemas.microsoft.com/office/drawing/2014/main" id="{FFA71133-57C5-4402-AE9C-A7EAE2A9EFF6}"/>
+                <a16:creationId xmlns:a16="http://schemas.microsoft.com/office/drawing/2014/main" id="{BF953499-8CEC-4485-80CD-F7E1A8868B7A}"/>
               </a:ext>
             </a:extLst>
           </p:cNvPr>
@@ -3056,7 +3056,7 @@
           <p:cNvPr id="10" name="">
             <a:extLst xmlns:a="http://schemas.openxmlformats.org/drawingml/2006/main">
               <a:ext uri="{FF2B5EF4-FFF2-40B4-BE49-F238E27FC236}">
-                <a16:creationId xmlns:a16="http://schemas.microsoft.com/office/drawing/2014/main" id="{A02191F8-47DF-4B0C-A11C-E41F947C2844}"/>
+                <a16:creationId xmlns:a16="http://schemas.microsoft.com/office/drawing/2014/main" id="{8636F5BD-CC58-40FD-A0BE-0840592382D6}"/>
               </a:ext>
             </a:extLst>
           </p:cNvPr>
@@ -3114,7 +3114,7 @@
           <p:cNvPr id="11" name="">
             <a:extLst xmlns:a="http://schemas.openxmlformats.org/drawingml/2006/main">
               <a:ext uri="{FF2B5EF4-FFF2-40B4-BE49-F238E27FC236}">
-                <a16:creationId xmlns:a16="http://schemas.microsoft.com/office/drawing/2014/main" id="{54AD8588-09F5-4204-B0DE-DAA6D6004AED}"/>
+                <a16:creationId xmlns:a16="http://schemas.microsoft.com/office/drawing/2014/main" id="{83130F7E-A185-4492-82C4-33A7EF78BAED}"/>
               </a:ext>
             </a:extLst>
           </p:cNvPr>
@@ -3172,7 +3172,7 @@
           <p:cNvPr id="12" name="">
             <a:extLst xmlns:a="http://schemas.openxmlformats.org/drawingml/2006/main">
               <a:ext uri="{FF2B5EF4-FFF2-40B4-BE49-F238E27FC236}">
-                <a16:creationId xmlns:a16="http://schemas.microsoft.com/office/drawing/2014/main" id="{01E468DA-28A2-4029-B2D0-6627A6F3686E}"/>
+                <a16:creationId xmlns:a16="http://schemas.microsoft.com/office/drawing/2014/main" id="{C31658C3-D03A-48F5-9514-E570D2200A3B}"/>
               </a:ext>
             </a:extLst>
           </p:cNvPr>
@@ -3230,7 +3230,7 @@
           <p:cNvPr id="13" name="">
             <a:extLst xmlns:a="http://schemas.openxmlformats.org/drawingml/2006/main">
               <a:ext uri="{FF2B5EF4-FFF2-40B4-BE49-F238E27FC236}">
-                <a16:creationId xmlns:a16="http://schemas.microsoft.com/office/drawing/2014/main" id="{80C5EB77-E387-42D7-AC47-7373DE2C5F80}"/>
+                <a16:creationId xmlns:a16="http://schemas.microsoft.com/office/drawing/2014/main" id="{E72B2D82-EBB4-4607-BC6F-A8E12A448ACA}"/>
               </a:ext>
             </a:extLst>
           </p:cNvPr>
@@ -3288,7 +3288,7 @@
           <p:cNvPr id="14" name="">
             <a:extLst xmlns:a="http://schemas.openxmlformats.org/drawingml/2006/main">
               <a:ext uri="{FF2B5EF4-FFF2-40B4-BE49-F238E27FC236}">
-                <a16:creationId xmlns:a16="http://schemas.microsoft.com/office/drawing/2014/main" id="{FDC6DAFC-3023-403D-92A2-39A4DD4985CD}"/>
+                <a16:creationId xmlns:a16="http://schemas.microsoft.com/office/drawing/2014/main" id="{D12C8575-6DFD-4E30-9E82-A74F8922A2E5}"/>
               </a:ext>
             </a:extLst>
           </p:cNvPr>
@@ -3346,7 +3346,7 @@
           <p:cNvPr id="15" name="">
             <a:extLst xmlns:a="http://schemas.openxmlformats.org/drawingml/2006/main">
               <a:ext uri="{FF2B5EF4-FFF2-40B4-BE49-F238E27FC236}">
-                <a16:creationId xmlns:a16="http://schemas.microsoft.com/office/drawing/2014/main" id="{1A22353B-B966-427B-91ED-28569682A017}"/>
+                <a16:creationId xmlns:a16="http://schemas.microsoft.com/office/drawing/2014/main" id="{0F82E7B5-5900-4BF7-9D9A-5156EA64AC8B}"/>
               </a:ext>
             </a:extLst>
           </p:cNvPr>
@@ -3404,7 +3404,7 @@
           <p:cNvPr id="16" name="">
             <a:extLst xmlns:a="http://schemas.openxmlformats.org/drawingml/2006/main">
               <a:ext uri="{FF2B5EF4-FFF2-40B4-BE49-F238E27FC236}">
-                <a16:creationId xmlns:a16="http://schemas.microsoft.com/office/drawing/2014/main" id="{3F663192-5963-4BA1-8B1D-DA38F821AD34}"/>
+                <a16:creationId xmlns:a16="http://schemas.microsoft.com/office/drawing/2014/main" id="{16228202-276A-47E2-9061-F8D726DF6257}"/>
               </a:ext>
             </a:extLst>
           </p:cNvPr>
@@ -3462,7 +3462,7 @@
           <p:cNvPr id="17" name="">
             <a:extLst xmlns:a="http://schemas.openxmlformats.org/drawingml/2006/main">
               <a:ext uri="{FF2B5EF4-FFF2-40B4-BE49-F238E27FC236}">
-                <a16:creationId xmlns:a16="http://schemas.microsoft.com/office/drawing/2014/main" id="{B0C8BBEE-19B1-4526-854B-33C2B1EDD6E6}"/>
+                <a16:creationId xmlns:a16="http://schemas.microsoft.com/office/drawing/2014/main" id="{1321B6F8-1603-44FE-9A77-9362F5F44944}"/>
               </a:ext>
             </a:extLst>
           </p:cNvPr>
@@ -3520,7 +3520,7 @@
           <p:cNvPr id="18" name="">
             <a:extLst xmlns:a="http://schemas.openxmlformats.org/drawingml/2006/main">
               <a:ext uri="{FF2B5EF4-FFF2-40B4-BE49-F238E27FC236}">
-                <a16:creationId xmlns:a16="http://schemas.microsoft.com/office/drawing/2014/main" id="{3DF4BE9F-BE4E-48B4-9B2F-5F9B8F018A98}"/>
+                <a16:creationId xmlns:a16="http://schemas.microsoft.com/office/drawing/2014/main" id="{C398EA34-270F-43FA-8CDC-4CECC700A919}"/>
               </a:ext>
             </a:extLst>
           </p:cNvPr>
@@ -3551,7 +3551,7 @@
           <p:cNvPr id="19" name="">
             <a:extLst xmlns:a="http://schemas.openxmlformats.org/drawingml/2006/main">
               <a:ext uri="{FF2B5EF4-FFF2-40B4-BE49-F238E27FC236}">
-                <a16:creationId xmlns:a16="http://schemas.microsoft.com/office/drawing/2014/main" id="{19B8B095-7755-4923-AFB1-DA231F8DFCB5}"/>
+                <a16:creationId xmlns:a16="http://schemas.microsoft.com/office/drawing/2014/main" id="{6B5861B8-106C-475E-8BE4-3F4795A4FA2B}"/>
               </a:ext>
             </a:extLst>
           </p:cNvPr>
@@ -3609,7 +3609,7 @@
           <p:cNvPr id="20" name="">
             <a:extLst xmlns:a="http://schemas.openxmlformats.org/drawingml/2006/main">
               <a:ext uri="{FF2B5EF4-FFF2-40B4-BE49-F238E27FC236}">
-                <a16:creationId xmlns:a16="http://schemas.microsoft.com/office/drawing/2014/main" id="{8DD68419-A3ED-412C-8289-C71F9FD095A5}"/>
+                <a16:creationId xmlns:a16="http://schemas.microsoft.com/office/drawing/2014/main" id="{DBF55BE2-E714-4D8C-9224-191E0B986FB2}"/>
               </a:ext>
             </a:extLst>
           </p:cNvPr>
@@ -3665,7 +3665,7 @@
     </p:spTree>
     <p:extLst>
       <p:ext uri="{BB962C8B-B14F-4D97-AF65-F5344CB8AC3E}">
-        <p14:creationId xmlns:p14="http://schemas.microsoft.com/office/powerpoint/2010/main" val="181570611"/>
+        <p14:creationId xmlns:p14="http://schemas.microsoft.com/office/powerpoint/2010/main" val="907914871"/>
       </p:ext>
     </p:extLst>
   </p:cSld>
@@ -3696,7 +3696,7 @@
           <p:cNvPr id="20" name="">
             <a:extLst xmlns:a="http://schemas.openxmlformats.org/drawingml/2006/main">
               <a:ext uri="{FF2B5EF4-FFF2-40B4-BE49-F238E27FC236}">
-                <a16:creationId xmlns:a16="http://schemas.microsoft.com/office/drawing/2014/main" id="{BD8C6DC2-0301-4E13-9CE0-ADA3E911097C}"/>
+                <a16:creationId xmlns:a16="http://schemas.microsoft.com/office/drawing/2014/main" id="{986A10C2-F3B8-496B-9816-962338E18D7E}"/>
               </a:ext>
             </a:extLst>
           </p:cNvPr>
@@ -3754,7 +3754,7 @@
           <p:cNvPr id="2" name="">
             <a:extLst xmlns:a="http://schemas.openxmlformats.org/drawingml/2006/main">
               <a:ext uri="{FF2B5EF4-FFF2-40B4-BE49-F238E27FC236}">
-                <a16:creationId xmlns:a16="http://schemas.microsoft.com/office/drawing/2014/main" id="{C228C9C5-F6B9-4237-90BE-04B0B7A8DE60}"/>
+                <a16:creationId xmlns:a16="http://schemas.microsoft.com/office/drawing/2014/main" id="{1622597C-67C3-4D00-B4D4-A4B35665F748}"/>
               </a:ext>
             </a:extLst>
           </p:cNvPr>
@@ -3812,7 +3812,7 @@
           <p:cNvPr id="3" name="">
             <a:extLst xmlns:a="http://schemas.openxmlformats.org/drawingml/2006/main">
               <a:ext uri="{FF2B5EF4-FFF2-40B4-BE49-F238E27FC236}">
-                <a16:creationId xmlns:a16="http://schemas.microsoft.com/office/drawing/2014/main" id="{BB65E344-7641-4C6C-B88C-31EB5F7C769D}"/>
+                <a16:creationId xmlns:a16="http://schemas.microsoft.com/office/drawing/2014/main" id="{57A38E18-75B5-4190-B300-E6EE1623CB27}"/>
               </a:ext>
             </a:extLst>
           </p:cNvPr>
@@ -3843,7 +3843,7 @@
           <p:cNvPr id="4" name="">
             <a:extLst xmlns:a="http://schemas.openxmlformats.org/drawingml/2006/main">
               <a:ext uri="{FF2B5EF4-FFF2-40B4-BE49-F238E27FC236}">
-                <a16:creationId xmlns:a16="http://schemas.microsoft.com/office/drawing/2014/main" id="{8676658A-C640-42DB-8F40-B3A32D7E5793}"/>
+                <a16:creationId xmlns:a16="http://schemas.microsoft.com/office/drawing/2014/main" id="{F6500E22-699A-4311-B0E0-E42B35044F84}"/>
               </a:ext>
             </a:extLst>
           </p:cNvPr>
@@ -3901,7 +3901,7 @@
           <p:cNvPr id="5" name="">
             <a:extLst xmlns:a="http://schemas.openxmlformats.org/drawingml/2006/main">
               <a:ext uri="{FF2B5EF4-FFF2-40B4-BE49-F238E27FC236}">
-                <a16:creationId xmlns:a16="http://schemas.microsoft.com/office/drawing/2014/main" id="{23BBCAD9-D747-42FF-BC57-4CFBC081E7F7}"/>
+                <a16:creationId xmlns:a16="http://schemas.microsoft.com/office/drawing/2014/main" id="{AE04B147-8B95-47F3-B03A-3C27C591A712}"/>
               </a:ext>
             </a:extLst>
           </p:cNvPr>
@@ -3959,7 +3959,7 @@
           <p:cNvPr id="6" name="">
             <a:extLst xmlns:a="http://schemas.openxmlformats.org/drawingml/2006/main">
               <a:ext uri="{FF2B5EF4-FFF2-40B4-BE49-F238E27FC236}">
-                <a16:creationId xmlns:a16="http://schemas.microsoft.com/office/drawing/2014/main" id="{46AE4A00-7F08-46AC-92BE-D67012246993}"/>
+                <a16:creationId xmlns:a16="http://schemas.microsoft.com/office/drawing/2014/main" id="{475A2D75-DEAB-412A-BE58-93EC69268921}"/>
               </a:ext>
             </a:extLst>
           </p:cNvPr>
@@ -3990,7 +3990,7 @@
           <p:cNvPr id="7" name="">
             <a:extLst xmlns:a="http://schemas.openxmlformats.org/drawingml/2006/main">
               <a:ext uri="{FF2B5EF4-FFF2-40B4-BE49-F238E27FC236}">
-                <a16:creationId xmlns:a16="http://schemas.microsoft.com/office/drawing/2014/main" id="{F23F1B3A-4A3D-42CE-9C2B-87490458E187}"/>
+                <a16:creationId xmlns:a16="http://schemas.microsoft.com/office/drawing/2014/main" id="{8980346F-B685-4B40-97E2-81556114A465}"/>
               </a:ext>
             </a:extLst>
           </p:cNvPr>
@@ -4048,7 +4048,7 @@
           <p:cNvPr id="8" name="">
             <a:extLst xmlns:a="http://schemas.openxmlformats.org/drawingml/2006/main">
               <a:ext uri="{FF2B5EF4-FFF2-40B4-BE49-F238E27FC236}">
-                <a16:creationId xmlns:a16="http://schemas.microsoft.com/office/drawing/2014/main" id="{3440F1E2-A603-4791-A517-224E7855B88A}"/>
+                <a16:creationId xmlns:a16="http://schemas.microsoft.com/office/drawing/2014/main" id="{04C9CEAB-1783-4FB1-B8DC-8002BC430CDF}"/>
               </a:ext>
             </a:extLst>
           </p:cNvPr>
@@ -4106,7 +4106,7 @@
           <p:cNvPr id="9" name="">
             <a:extLst xmlns:a="http://schemas.openxmlformats.org/drawingml/2006/main">
               <a:ext uri="{FF2B5EF4-FFF2-40B4-BE49-F238E27FC236}">
-                <a16:creationId xmlns:a16="http://schemas.microsoft.com/office/drawing/2014/main" id="{DCC70AD6-704F-4AD0-91CF-2ECFA3E04C2D}"/>
+                <a16:creationId xmlns:a16="http://schemas.microsoft.com/office/drawing/2014/main" id="{F2B0B092-EBB7-4EA5-AD78-88524FC969EE}"/>
               </a:ext>
             </a:extLst>
           </p:cNvPr>
@@ -4164,7 +4164,7 @@
           <p:cNvPr id="10" name="">
             <a:extLst xmlns:a="http://schemas.openxmlformats.org/drawingml/2006/main">
               <a:ext uri="{FF2B5EF4-FFF2-40B4-BE49-F238E27FC236}">
-                <a16:creationId xmlns:a16="http://schemas.microsoft.com/office/drawing/2014/main" id="{A9299C0A-2A1F-431F-B59A-A0C158BC4B98}"/>
+                <a16:creationId xmlns:a16="http://schemas.microsoft.com/office/drawing/2014/main" id="{D6881B19-1129-4C4E-A270-AA861CC178E9}"/>
               </a:ext>
             </a:extLst>
           </p:cNvPr>
@@ -4195,7 +4195,7 @@
           <p:cNvPr id="11" name="">
             <a:extLst xmlns:a="http://schemas.openxmlformats.org/drawingml/2006/main">
               <a:ext uri="{FF2B5EF4-FFF2-40B4-BE49-F238E27FC236}">
-                <a16:creationId xmlns:a16="http://schemas.microsoft.com/office/drawing/2014/main" id="{973D2DD1-34FE-4B5E-96A1-877E67BC5E59}"/>
+                <a16:creationId xmlns:a16="http://schemas.microsoft.com/office/drawing/2014/main" id="{B69982B9-7373-492F-B7C4-837DAD0492AB}"/>
               </a:ext>
             </a:extLst>
           </p:cNvPr>
@@ -4253,7 +4253,7 @@
           <p:cNvPr id="12" name="">
             <a:extLst xmlns:a="http://schemas.openxmlformats.org/drawingml/2006/main">
               <a:ext uri="{FF2B5EF4-FFF2-40B4-BE49-F238E27FC236}">
-                <a16:creationId xmlns:a16="http://schemas.microsoft.com/office/drawing/2014/main" id="{C9525B54-AD5A-4845-9443-27E2381B4B68}"/>
+                <a16:creationId xmlns:a16="http://schemas.microsoft.com/office/drawing/2014/main" id="{D28CA538-AA1C-41B2-908B-4038569C8E2C}"/>
               </a:ext>
             </a:extLst>
           </p:cNvPr>
@@ -4311,7 +4311,7 @@
           <p:cNvPr id="13" name="">
             <a:extLst xmlns:a="http://schemas.openxmlformats.org/drawingml/2006/main">
               <a:ext uri="{FF2B5EF4-FFF2-40B4-BE49-F238E27FC236}">
-                <a16:creationId xmlns:a16="http://schemas.microsoft.com/office/drawing/2014/main" id="{C208AAB7-C900-471A-A58B-AF151232AB58}"/>
+                <a16:creationId xmlns:a16="http://schemas.microsoft.com/office/drawing/2014/main" id="{95467A0D-8F6C-46EC-815C-FBDCDA490A05}"/>
               </a:ext>
             </a:extLst>
           </p:cNvPr>
@@ -4369,7 +4369,7 @@
           <p:cNvPr id="14" name="">
             <a:extLst xmlns:a="http://schemas.openxmlformats.org/drawingml/2006/main">
               <a:ext uri="{FF2B5EF4-FFF2-40B4-BE49-F238E27FC236}">
-                <a16:creationId xmlns:a16="http://schemas.microsoft.com/office/drawing/2014/main" id="{AB710642-D767-4244-8C02-D5C22BE598C6}"/>
+                <a16:creationId xmlns:a16="http://schemas.microsoft.com/office/drawing/2014/main" id="{9F5502D4-DD96-42B4-A376-0F6D5AFFAEE7}"/>
               </a:ext>
             </a:extLst>
           </p:cNvPr>
@@ -4400,7 +4400,7 @@
           <p:cNvPr id="15" name="">
             <a:extLst xmlns:a="http://schemas.openxmlformats.org/drawingml/2006/main">
               <a:ext uri="{FF2B5EF4-FFF2-40B4-BE49-F238E27FC236}">
-                <a16:creationId xmlns:a16="http://schemas.microsoft.com/office/drawing/2014/main" id="{CB30136C-80AD-443F-82AE-106CEEC6D750}"/>
+                <a16:creationId xmlns:a16="http://schemas.microsoft.com/office/drawing/2014/main" id="{D216C19C-FA0D-4867-8D9B-9F4FEA2272C3}"/>
               </a:ext>
             </a:extLst>
           </p:cNvPr>
@@ -4458,7 +4458,7 @@
           <p:cNvPr id="16" name="">
             <a:extLst xmlns:a="http://schemas.openxmlformats.org/drawingml/2006/main">
               <a:ext uri="{FF2B5EF4-FFF2-40B4-BE49-F238E27FC236}">
-                <a16:creationId xmlns:a16="http://schemas.microsoft.com/office/drawing/2014/main" id="{A183F65A-692C-426C-A87A-3F7259ADB0C6}"/>
+                <a16:creationId xmlns:a16="http://schemas.microsoft.com/office/drawing/2014/main" id="{77A9CF18-3FA8-4F1A-BE63-2FA9985F1AEC}"/>
               </a:ext>
             </a:extLst>
           </p:cNvPr>
@@ -4516,7 +4516,7 @@
           <p:cNvPr id="17" name="">
             <a:extLst xmlns:a="http://schemas.openxmlformats.org/drawingml/2006/main">
               <a:ext uri="{FF2B5EF4-FFF2-40B4-BE49-F238E27FC236}">
-                <a16:creationId xmlns:a16="http://schemas.microsoft.com/office/drawing/2014/main" id="{352647FD-11B8-47BE-A81E-8C1CAD6D8851}"/>
+                <a16:creationId xmlns:a16="http://schemas.microsoft.com/office/drawing/2014/main" id="{11BD1FD3-5185-42F9-9FE7-D6CDBEBF7DDD}"/>
               </a:ext>
             </a:extLst>
           </p:cNvPr>
@@ -4574,7 +4574,7 @@
           <p:cNvPr id="18" name="">
             <a:extLst xmlns:a="http://schemas.openxmlformats.org/drawingml/2006/main">
               <a:ext uri="{FF2B5EF4-FFF2-40B4-BE49-F238E27FC236}">
-                <a16:creationId xmlns:a16="http://schemas.microsoft.com/office/drawing/2014/main" id="{AAA87CF0-1BFA-43F0-92C2-46F3599FBA80}"/>
+                <a16:creationId xmlns:a16="http://schemas.microsoft.com/office/drawing/2014/main" id="{F918E383-15CE-4C85-9C32-518528B3D445}"/>
               </a:ext>
             </a:extLst>
           </p:cNvPr>
@@ -4632,7 +4632,7 @@
           <p:cNvPr id="19" name="">
             <a:extLst xmlns:a="http://schemas.openxmlformats.org/drawingml/2006/main">
               <a:ext uri="{FF2B5EF4-FFF2-40B4-BE49-F238E27FC236}">
-                <a16:creationId xmlns:a16="http://schemas.microsoft.com/office/drawing/2014/main" id="{99F55ABD-29AA-41CB-8DCD-68D7B18EBA70}"/>
+                <a16:creationId xmlns:a16="http://schemas.microsoft.com/office/drawing/2014/main" id="{A96F536A-B22E-441D-863D-65C4187B46C2}"/>
               </a:ext>
             </a:extLst>
           </p:cNvPr>
@@ -4688,7 +4688,7 @@
     </p:spTree>
     <p:extLst>
       <p:ext uri="{BB962C8B-B14F-4D97-AF65-F5344CB8AC3E}">
-        <p14:creationId xmlns:p14="http://schemas.microsoft.com/office/powerpoint/2010/main" val="564010590"/>
+        <p14:creationId xmlns:p14="http://schemas.microsoft.com/office/powerpoint/2010/main" val="73848759"/>
       </p:ext>
     </p:extLst>
   </p:cSld>
@@ -4719,7 +4719,7 @@
           <p:cNvPr id="15" name="">
             <a:extLst xmlns:a="http://schemas.openxmlformats.org/drawingml/2006/main">
               <a:ext uri="{FF2B5EF4-FFF2-40B4-BE49-F238E27FC236}">
-                <a16:creationId xmlns:a16="http://schemas.microsoft.com/office/drawing/2014/main" id="{6BFE9E31-01AD-426B-B8D5-892337921E5A}"/>
+                <a16:creationId xmlns:a16="http://schemas.microsoft.com/office/drawing/2014/main" id="{0171602E-15EA-4565-AF77-62DBC9FD3AB3}"/>
               </a:ext>
             </a:extLst>
           </p:cNvPr>
@@ -4777,7 +4777,7 @@
           <p:cNvPr id="2" name="">
             <a:extLst xmlns:a="http://schemas.openxmlformats.org/drawingml/2006/main">
               <a:ext uri="{FF2B5EF4-FFF2-40B4-BE49-F238E27FC236}">
-                <a16:creationId xmlns:a16="http://schemas.microsoft.com/office/drawing/2014/main" id="{F22F06FB-13BA-4ECA-BF6A-673E61B029B9}"/>
+                <a16:creationId xmlns:a16="http://schemas.microsoft.com/office/drawing/2014/main" id="{1F137F81-7B68-4DB2-8755-D3781D51AF94}"/>
               </a:ext>
             </a:extLst>
           </p:cNvPr>
@@ -4835,7 +4835,7 @@
           <p:cNvPr id="3" name="">
             <a:extLst xmlns:a="http://schemas.openxmlformats.org/drawingml/2006/main">
               <a:ext uri="{FF2B5EF4-FFF2-40B4-BE49-F238E27FC236}">
-                <a16:creationId xmlns:a16="http://schemas.microsoft.com/office/drawing/2014/main" id="{AA129543-CCFB-4596-B047-5F2A34CAE976}"/>
+                <a16:creationId xmlns:a16="http://schemas.microsoft.com/office/drawing/2014/main" id="{40D0A2D7-8A58-4FB8-87B7-A2B75A9F39AA}"/>
               </a:ext>
             </a:extLst>
           </p:cNvPr>
@@ -4866,7 +4866,7 @@
           <p:cNvPr id="4" name="">
             <a:extLst xmlns:a="http://schemas.openxmlformats.org/drawingml/2006/main">
               <a:ext uri="{FF2B5EF4-FFF2-40B4-BE49-F238E27FC236}">
-                <a16:creationId xmlns:a16="http://schemas.microsoft.com/office/drawing/2014/main" id="{A3E6C15C-E70B-41C1-B30C-56A6B797D029}"/>
+                <a16:creationId xmlns:a16="http://schemas.microsoft.com/office/drawing/2014/main" id="{341D0BE6-2C1B-4CF6-AB3F-02D2404F50A4}"/>
               </a:ext>
             </a:extLst>
           </p:cNvPr>
@@ -4924,7 +4924,7 @@
           <p:cNvPr id="5" name="">
             <a:extLst xmlns:a="http://schemas.openxmlformats.org/drawingml/2006/main">
               <a:ext uri="{FF2B5EF4-FFF2-40B4-BE49-F238E27FC236}">
-                <a16:creationId xmlns:a16="http://schemas.microsoft.com/office/drawing/2014/main" id="{CF5B4FAD-51D7-4277-BFDE-183F8BBBAE6D}"/>
+                <a16:creationId xmlns:a16="http://schemas.microsoft.com/office/drawing/2014/main" id="{591CE022-2974-4629-9F8C-434516FB45FC}"/>
               </a:ext>
             </a:extLst>
           </p:cNvPr>
@@ -4982,7 +4982,7 @@
           <p:cNvPr id="6" name="">
             <a:extLst xmlns:a="http://schemas.openxmlformats.org/drawingml/2006/main">
               <a:ext uri="{FF2B5EF4-FFF2-40B4-BE49-F238E27FC236}">
-                <a16:creationId xmlns:a16="http://schemas.microsoft.com/office/drawing/2014/main" id="{538FA3B8-D7C3-4828-8445-8A36B65C9D36}"/>
+                <a16:creationId xmlns:a16="http://schemas.microsoft.com/office/drawing/2014/main" id="{B6B6705B-A8BA-42CB-A4C1-9F9FF1A6CDD1}"/>
               </a:ext>
             </a:extLst>
           </p:cNvPr>
@@ -5040,7 +5040,7 @@
           <p:cNvPr id="7" name="">
             <a:extLst xmlns:a="http://schemas.openxmlformats.org/drawingml/2006/main">
               <a:ext uri="{FF2B5EF4-FFF2-40B4-BE49-F238E27FC236}">
-                <a16:creationId xmlns:a16="http://schemas.microsoft.com/office/drawing/2014/main" id="{08C37E75-9CCA-4ACF-9F3A-7DB831EE8EA0}"/>
+                <a16:creationId xmlns:a16="http://schemas.microsoft.com/office/drawing/2014/main" id="{2A0E355E-484C-4214-95F3-2E1DE33A5EC3}"/>
               </a:ext>
             </a:extLst>
           </p:cNvPr>
@@ -5071,7 +5071,7 @@
           <p:cNvPr id="8" name="">
             <a:extLst xmlns:a="http://schemas.openxmlformats.org/drawingml/2006/main">
               <a:ext uri="{FF2B5EF4-FFF2-40B4-BE49-F238E27FC236}">
-                <a16:creationId xmlns:a16="http://schemas.microsoft.com/office/drawing/2014/main" id="{E6467D14-B445-4AC9-8677-71E806B23E81}"/>
+                <a16:creationId xmlns:a16="http://schemas.microsoft.com/office/drawing/2014/main" id="{8DC7D6CC-83F3-4295-89D5-3B9339DFC58B}"/>
               </a:ext>
             </a:extLst>
           </p:cNvPr>
@@ -5129,7 +5129,7 @@
           <p:cNvPr id="9" name="">
             <a:extLst xmlns:a="http://schemas.openxmlformats.org/drawingml/2006/main">
               <a:ext uri="{FF2B5EF4-FFF2-40B4-BE49-F238E27FC236}">
-                <a16:creationId xmlns:a16="http://schemas.microsoft.com/office/drawing/2014/main" id="{6946796A-65B4-42D8-8AA2-0E308AFF907B}"/>
+                <a16:creationId xmlns:a16="http://schemas.microsoft.com/office/drawing/2014/main" id="{82E2D975-4581-4BEA-8A7A-7736FA8439C5}"/>
               </a:ext>
             </a:extLst>
           </p:cNvPr>
@@ -5187,7 +5187,7 @@
           <p:cNvPr id="10" name="">
             <a:extLst xmlns:a="http://schemas.openxmlformats.org/drawingml/2006/main">
               <a:ext uri="{FF2B5EF4-FFF2-40B4-BE49-F238E27FC236}">
-                <a16:creationId xmlns:a16="http://schemas.microsoft.com/office/drawing/2014/main" id="{004F05C8-2080-4AA1-92EA-6A37F281A4B1}"/>
+                <a16:creationId xmlns:a16="http://schemas.microsoft.com/office/drawing/2014/main" id="{F65264D6-3474-4A8E-ACB5-5ECF92B39B80}"/>
               </a:ext>
             </a:extLst>
           </p:cNvPr>
@@ -5245,7 +5245,7 @@
           <p:cNvPr id="11" name="">
             <a:extLst xmlns:a="http://schemas.openxmlformats.org/drawingml/2006/main">
               <a:ext uri="{FF2B5EF4-FFF2-40B4-BE49-F238E27FC236}">
-                <a16:creationId xmlns:a16="http://schemas.microsoft.com/office/drawing/2014/main" id="{1C1FF801-ABB7-4625-A634-6A3E80AFB935}"/>
+                <a16:creationId xmlns:a16="http://schemas.microsoft.com/office/drawing/2014/main" id="{D29D5260-4E85-4AA3-A4C0-C9165713FE13}"/>
               </a:ext>
             </a:extLst>
           </p:cNvPr>
@@ -5303,7 +5303,7 @@
           <p:cNvPr id="12" name="">
             <a:extLst xmlns:a="http://schemas.openxmlformats.org/drawingml/2006/main">
               <a:ext uri="{FF2B5EF4-FFF2-40B4-BE49-F238E27FC236}">
-                <a16:creationId xmlns:a16="http://schemas.microsoft.com/office/drawing/2014/main" id="{9FE29A33-F17E-4B9E-A3B7-C9F4521D2D38}"/>
+                <a16:creationId xmlns:a16="http://schemas.microsoft.com/office/drawing/2014/main" id="{76415FD3-524A-467D-8808-0E903DF2E2B8}"/>
               </a:ext>
             </a:extLst>
           </p:cNvPr>
@@ -5361,7 +5361,7 @@
           <p:cNvPr id="13" name="">
             <a:extLst xmlns:a="http://schemas.openxmlformats.org/drawingml/2006/main">
               <a:ext uri="{FF2B5EF4-FFF2-40B4-BE49-F238E27FC236}">
-                <a16:creationId xmlns:a16="http://schemas.microsoft.com/office/drawing/2014/main" id="{278CB492-E40D-43D8-B122-A6C3D3771421}"/>
+                <a16:creationId xmlns:a16="http://schemas.microsoft.com/office/drawing/2014/main" id="{481BDA03-02C8-44C6-96C0-A4770C11F157}"/>
               </a:ext>
             </a:extLst>
           </p:cNvPr>
@@ -5419,7 +5419,7 @@
           <p:cNvPr id="14" name="">
             <a:extLst xmlns:a="http://schemas.openxmlformats.org/drawingml/2006/main">
               <a:ext uri="{FF2B5EF4-FFF2-40B4-BE49-F238E27FC236}">
-                <a16:creationId xmlns:a16="http://schemas.microsoft.com/office/drawing/2014/main" id="{95C66E8E-38AB-4CEB-97C7-1D4CE9CD7705}"/>
+                <a16:creationId xmlns:a16="http://schemas.microsoft.com/office/drawing/2014/main" id="{C9A73155-E78A-4916-9EC1-AD136CDA1776}"/>
               </a:ext>
             </a:extLst>
           </p:cNvPr>
@@ -5475,7 +5475,7 @@
     </p:spTree>
     <p:extLst>
       <p:ext uri="{BB962C8B-B14F-4D97-AF65-F5344CB8AC3E}">
-        <p14:creationId xmlns:p14="http://schemas.microsoft.com/office/powerpoint/2010/main" val="2048908961"/>
+        <p14:creationId xmlns:p14="http://schemas.microsoft.com/office/powerpoint/2010/main" val="244160889"/>
       </p:ext>
     </p:extLst>
   </p:cSld>
@@ -5506,7 +5506,7 @@
           <p:cNvPr id="6" name="">
             <a:extLst xmlns:a="http://schemas.openxmlformats.org/drawingml/2006/main">
               <a:ext uri="{FF2B5EF4-FFF2-40B4-BE49-F238E27FC236}">
-                <a16:creationId xmlns:a16="http://schemas.microsoft.com/office/drawing/2014/main" id="{AD26A07E-A233-4989-90E5-0D39B3CEDB3E}"/>
+                <a16:creationId xmlns:a16="http://schemas.microsoft.com/office/drawing/2014/main" id="{F94DBFCF-F87F-4041-9FA1-646FDA6087B0}"/>
               </a:ext>
             </a:extLst>
           </p:cNvPr>
@@ -5564,7 +5564,7 @@
           <p:cNvPr id="2" name="">
             <a:extLst xmlns:a="http://schemas.openxmlformats.org/drawingml/2006/main">
               <a:ext uri="{FF2B5EF4-FFF2-40B4-BE49-F238E27FC236}">
-                <a16:creationId xmlns:a16="http://schemas.microsoft.com/office/drawing/2014/main" id="{7C05174C-57F1-4FDD-B631-B6B135ADD13E}"/>
+                <a16:creationId xmlns:a16="http://schemas.microsoft.com/office/drawing/2014/main" id="{62792AC8-C57A-4E03-BA17-F073D7687D87}"/>
               </a:ext>
             </a:extLst>
           </p:cNvPr>
@@ -5668,7 +5668,7 @@
           <p:cNvPr id="3" name="">
             <a:extLst xmlns:a="http://schemas.openxmlformats.org/drawingml/2006/main">
               <a:ext uri="{FF2B5EF4-FFF2-40B4-BE49-F238E27FC236}">
-                <a16:creationId xmlns:a16="http://schemas.microsoft.com/office/drawing/2014/main" id="{25C26FD1-467A-44ED-9736-BD9E239E0F07}"/>
+                <a16:creationId xmlns:a16="http://schemas.microsoft.com/office/drawing/2014/main" id="{AB4B4FDF-5815-4346-9104-58034A3420AF}"/>
               </a:ext>
             </a:extLst>
           </p:cNvPr>
@@ -5726,7 +5726,7 @@
           <p:cNvPr id="4" name="">
             <a:extLst xmlns:a="http://schemas.openxmlformats.org/drawingml/2006/main">
               <a:ext uri="{FF2B5EF4-FFF2-40B4-BE49-F238E27FC236}">
-                <a16:creationId xmlns:a16="http://schemas.microsoft.com/office/drawing/2014/main" id="{970BCBAC-2C2C-4E3E-A991-FD8E8685C303}"/>
+                <a16:creationId xmlns:a16="http://schemas.microsoft.com/office/drawing/2014/main" id="{690AB62D-B44B-4AC0-9CFB-4A3FBBBC14E7}"/>
               </a:ext>
             </a:extLst>
           </p:cNvPr>
@@ -5784,7 +5784,7 @@
           <p:cNvPr id="5" name="">
             <a:extLst xmlns:a="http://schemas.openxmlformats.org/drawingml/2006/main">
               <a:ext uri="{FF2B5EF4-FFF2-40B4-BE49-F238E27FC236}">
-                <a16:creationId xmlns:a16="http://schemas.microsoft.com/office/drawing/2014/main" id="{5A562CDC-31A1-4188-9A09-6E74DE11056D}"/>
+                <a16:creationId xmlns:a16="http://schemas.microsoft.com/office/drawing/2014/main" id="{2338D5BB-2E8A-4C9A-A520-AD756D2FF531}"/>
               </a:ext>
             </a:extLst>
           </p:cNvPr>
@@ -5840,7 +5840,7 @@
     </p:spTree>
     <p:extLst>
       <p:ext uri="{BB962C8B-B14F-4D97-AF65-F5344CB8AC3E}">
-        <p14:creationId xmlns:p14="http://schemas.microsoft.com/office/powerpoint/2010/main" val="722298080"/>
+        <p14:creationId xmlns:p14="http://schemas.microsoft.com/office/powerpoint/2010/main" val="90662431"/>
       </p:ext>
     </p:extLst>
   </p:cSld>
@@ -5871,7 +5871,7 @@
           <p:cNvPr id="19" name="">
             <a:extLst xmlns:a="http://schemas.openxmlformats.org/drawingml/2006/main">
               <a:ext uri="{FF2B5EF4-FFF2-40B4-BE49-F238E27FC236}">
-                <a16:creationId xmlns:a16="http://schemas.microsoft.com/office/drawing/2014/main" id="{BF6BEDA9-690C-4A77-9F91-812435164015}"/>
+                <a16:creationId xmlns:a16="http://schemas.microsoft.com/office/drawing/2014/main" id="{0ECDDEC3-86CE-4F49-A1CF-BFE4E50850F8}"/>
               </a:ext>
             </a:extLst>
           </p:cNvPr>
@@ -5929,7 +5929,7 @@
           <p:cNvPr id="2" name="">
             <a:extLst xmlns:a="http://schemas.openxmlformats.org/drawingml/2006/main">
               <a:ext uri="{FF2B5EF4-FFF2-40B4-BE49-F238E27FC236}">
-                <a16:creationId xmlns:a16="http://schemas.microsoft.com/office/drawing/2014/main" id="{38E300C2-0921-4588-8B7A-7274676D2907}"/>
+                <a16:creationId xmlns:a16="http://schemas.microsoft.com/office/drawing/2014/main" id="{574B060C-C398-42CD-9FFE-E7A5F5AEC2D8}"/>
               </a:ext>
             </a:extLst>
           </p:cNvPr>
@@ -5987,7 +5987,7 @@
           <p:cNvPr id="3" name="">
             <a:extLst xmlns:a="http://schemas.openxmlformats.org/drawingml/2006/main">
               <a:ext uri="{FF2B5EF4-FFF2-40B4-BE49-F238E27FC236}">
-                <a16:creationId xmlns:a16="http://schemas.microsoft.com/office/drawing/2014/main" id="{58402D66-234B-48DC-86E2-B98D20709F5E}"/>
+                <a16:creationId xmlns:a16="http://schemas.microsoft.com/office/drawing/2014/main" id="{63E12ADB-2D5E-4492-8A46-B2057D11B866}"/>
               </a:ext>
             </a:extLst>
           </p:cNvPr>
@@ -6018,7 +6018,7 @@
           <p:cNvPr id="4" name="">
             <a:extLst xmlns:a="http://schemas.openxmlformats.org/drawingml/2006/main">
               <a:ext uri="{FF2B5EF4-FFF2-40B4-BE49-F238E27FC236}">
-                <a16:creationId xmlns:a16="http://schemas.microsoft.com/office/drawing/2014/main" id="{B932A740-F259-49E4-A12F-9B6A0ACC0C4E}"/>
+                <a16:creationId xmlns:a16="http://schemas.microsoft.com/office/drawing/2014/main" id="{5ECA5728-624E-43E6-8540-02C030D8D05D}"/>
               </a:ext>
             </a:extLst>
           </p:cNvPr>
@@ -6076,7 +6076,7 @@
           <p:cNvPr id="5" name="">
             <a:extLst xmlns:a="http://schemas.openxmlformats.org/drawingml/2006/main">
               <a:ext uri="{FF2B5EF4-FFF2-40B4-BE49-F238E27FC236}">
-                <a16:creationId xmlns:a16="http://schemas.microsoft.com/office/drawing/2014/main" id="{004BFD42-9B49-43B2-BD77-DCC6E65E6421}"/>
+                <a16:creationId xmlns:a16="http://schemas.microsoft.com/office/drawing/2014/main" id="{319D274A-5948-477B-991D-182801D2EF9C}"/>
               </a:ext>
             </a:extLst>
           </p:cNvPr>
@@ -6134,7 +6134,7 @@
           <p:cNvPr id="6" name="">
             <a:extLst xmlns:a="http://schemas.openxmlformats.org/drawingml/2006/main">
               <a:ext uri="{FF2B5EF4-FFF2-40B4-BE49-F238E27FC236}">
-                <a16:creationId xmlns:a16="http://schemas.microsoft.com/office/drawing/2014/main" id="{C61D193B-AFD5-4D45-9EE1-47D56D8A1AF1}"/>
+                <a16:creationId xmlns:a16="http://schemas.microsoft.com/office/drawing/2014/main" id="{C531BE01-6E96-4554-8A74-DA62F035FD15}"/>
               </a:ext>
             </a:extLst>
           </p:cNvPr>
@@ -6165,7 +6165,7 @@
           <p:cNvPr id="7" name="">
             <a:extLst xmlns:a="http://schemas.openxmlformats.org/drawingml/2006/main">
               <a:ext uri="{FF2B5EF4-FFF2-40B4-BE49-F238E27FC236}">
-                <a16:creationId xmlns:a16="http://schemas.microsoft.com/office/drawing/2014/main" id="{A89FB901-6AE2-4044-BC72-1267D4F591F2}"/>
+                <a16:creationId xmlns:a16="http://schemas.microsoft.com/office/drawing/2014/main" id="{606E5988-2724-475B-A6AD-147FF8827F29}"/>
               </a:ext>
             </a:extLst>
           </p:cNvPr>
@@ -6223,7 +6223,7 @@
           <p:cNvPr id="8" name="">
             <a:extLst xmlns:a="http://schemas.openxmlformats.org/drawingml/2006/main">
               <a:ext uri="{FF2B5EF4-FFF2-40B4-BE49-F238E27FC236}">
-                <a16:creationId xmlns:a16="http://schemas.microsoft.com/office/drawing/2014/main" id="{2B099421-A494-41BF-BEA4-0DDB03026FF4}"/>
+                <a16:creationId xmlns:a16="http://schemas.microsoft.com/office/drawing/2014/main" id="{53476050-95F2-4B59-8136-08E01EE81507}"/>
               </a:ext>
             </a:extLst>
           </p:cNvPr>
@@ -6281,7 +6281,7 @@
           <p:cNvPr id="9" name="">
             <a:extLst xmlns:a="http://schemas.openxmlformats.org/drawingml/2006/main">
               <a:ext uri="{FF2B5EF4-FFF2-40B4-BE49-F238E27FC236}">
-                <a16:creationId xmlns:a16="http://schemas.microsoft.com/office/drawing/2014/main" id="{5EBB1DA1-77CD-4B12-86F8-7AFA687E0A7D}"/>
+                <a16:creationId xmlns:a16="http://schemas.microsoft.com/office/drawing/2014/main" id="{301ECBF0-8E7C-4567-B795-15B84436A66E}"/>
               </a:ext>
             </a:extLst>
           </p:cNvPr>
@@ -6339,7 +6339,7 @@
           <p:cNvPr id="10" name="">
             <a:extLst xmlns:a="http://schemas.openxmlformats.org/drawingml/2006/main">
               <a:ext uri="{FF2B5EF4-FFF2-40B4-BE49-F238E27FC236}">
-                <a16:creationId xmlns:a16="http://schemas.microsoft.com/office/drawing/2014/main" id="{291D51F9-0225-4371-89ED-7AD5B628EBCC}"/>
+                <a16:creationId xmlns:a16="http://schemas.microsoft.com/office/drawing/2014/main" id="{8A930FF0-DC8E-4A4C-AF8B-23F5F2B05CB4}"/>
               </a:ext>
             </a:extLst>
           </p:cNvPr>
@@ -6370,7 +6370,7 @@
           <p:cNvPr id="11" name="">
             <a:extLst xmlns:a="http://schemas.openxmlformats.org/drawingml/2006/main">
               <a:ext uri="{FF2B5EF4-FFF2-40B4-BE49-F238E27FC236}">
-                <a16:creationId xmlns:a16="http://schemas.microsoft.com/office/drawing/2014/main" id="{9EC8AA5D-D533-46F0-BC45-B9E53B164A7C}"/>
+                <a16:creationId xmlns:a16="http://schemas.microsoft.com/office/drawing/2014/main" id="{AA990036-8F7F-47AE-88F3-ADFC123F115A}"/>
               </a:ext>
             </a:extLst>
           </p:cNvPr>
@@ -6428,7 +6428,7 @@
           <p:cNvPr id="12" name="">
             <a:extLst xmlns:a="http://schemas.openxmlformats.org/drawingml/2006/main">
               <a:ext uri="{FF2B5EF4-FFF2-40B4-BE49-F238E27FC236}">
-                <a16:creationId xmlns:a16="http://schemas.microsoft.com/office/drawing/2014/main" id="{8DC6C425-A3F6-4242-8540-B9482F048E4C}"/>
+                <a16:creationId xmlns:a16="http://schemas.microsoft.com/office/drawing/2014/main" id="{7EE4E9B5-ED0B-4FB9-809D-14A85AD50848}"/>
               </a:ext>
             </a:extLst>
           </p:cNvPr>
@@ -6486,7 +6486,7 @@
           <p:cNvPr id="13" name="">
             <a:extLst xmlns:a="http://schemas.openxmlformats.org/drawingml/2006/main">
               <a:ext uri="{FF2B5EF4-FFF2-40B4-BE49-F238E27FC236}">
-                <a16:creationId xmlns:a16="http://schemas.microsoft.com/office/drawing/2014/main" id="{B609F003-16C3-4C7C-886D-AA2D5E95E953}"/>
+                <a16:creationId xmlns:a16="http://schemas.microsoft.com/office/drawing/2014/main" id="{4B69DBC1-34DE-4104-B600-FB9DE855196E}"/>
               </a:ext>
             </a:extLst>
           </p:cNvPr>
@@ -6544,7 +6544,7 @@
           <p:cNvPr id="14" name="">
             <a:extLst xmlns:a="http://schemas.openxmlformats.org/drawingml/2006/main">
               <a:ext uri="{FF2B5EF4-FFF2-40B4-BE49-F238E27FC236}">
-                <a16:creationId xmlns:a16="http://schemas.microsoft.com/office/drawing/2014/main" id="{C71E673E-DF64-4B69-85DB-9DE93FD6AA25}"/>
+                <a16:creationId xmlns:a16="http://schemas.microsoft.com/office/drawing/2014/main" id="{94AF038B-1F64-44C7-8056-840F0C7CE39C}"/>
               </a:ext>
             </a:extLst>
           </p:cNvPr>
@@ -6575,7 +6575,7 @@
           <p:cNvPr id="15" name="">
             <a:extLst xmlns:a="http://schemas.openxmlformats.org/drawingml/2006/main">
               <a:ext uri="{FF2B5EF4-FFF2-40B4-BE49-F238E27FC236}">
-                <a16:creationId xmlns:a16="http://schemas.microsoft.com/office/drawing/2014/main" id="{6DBD4F5F-E1C1-4430-B286-B5E3110F9706}"/>
+                <a16:creationId xmlns:a16="http://schemas.microsoft.com/office/drawing/2014/main" id="{F0EEA62A-1FEA-4372-9B6F-863580DB2117}"/>
               </a:ext>
             </a:extLst>
           </p:cNvPr>
@@ -6633,7 +6633,7 @@
           <p:cNvPr id="16" name="">
             <a:extLst xmlns:a="http://schemas.openxmlformats.org/drawingml/2006/main">
               <a:ext uri="{FF2B5EF4-FFF2-40B4-BE49-F238E27FC236}">
-                <a16:creationId xmlns:a16="http://schemas.microsoft.com/office/drawing/2014/main" id="{AB8BFBCD-AFF3-4650-8404-6857D03FB1E9}"/>
+                <a16:creationId xmlns:a16="http://schemas.microsoft.com/office/drawing/2014/main" id="{AAA3C2D8-5157-4685-A358-6CFB4005EF09}"/>
               </a:ext>
             </a:extLst>
           </p:cNvPr>
@@ -6691,7 +6691,7 @@
           <p:cNvPr id="17" name="">
             <a:extLst xmlns:a="http://schemas.openxmlformats.org/drawingml/2006/main">
               <a:ext uri="{FF2B5EF4-FFF2-40B4-BE49-F238E27FC236}">
-                <a16:creationId xmlns:a16="http://schemas.microsoft.com/office/drawing/2014/main" id="{3D30448B-8658-4A8D-B40D-56F9DAE3B592}"/>
+                <a16:creationId xmlns:a16="http://schemas.microsoft.com/office/drawing/2014/main" id="{82267AF5-423E-4D39-9F87-37A588F75F07}"/>
               </a:ext>
             </a:extLst>
           </p:cNvPr>
@@ -6749,7 +6749,7 @@
           <p:cNvPr id="18" name="">
             <a:extLst xmlns:a="http://schemas.openxmlformats.org/drawingml/2006/main">
               <a:ext uri="{FF2B5EF4-FFF2-40B4-BE49-F238E27FC236}">
-                <a16:creationId xmlns:a16="http://schemas.microsoft.com/office/drawing/2014/main" id="{6CA22634-83C7-43F4-80F8-074C14E4A0AF}"/>
+                <a16:creationId xmlns:a16="http://schemas.microsoft.com/office/drawing/2014/main" id="{EF3C11F8-E9E0-4F97-B0B8-CB29037DECE4}"/>
               </a:ext>
             </a:extLst>
           </p:cNvPr>
@@ -6805,7 +6805,7 @@
     </p:spTree>
     <p:extLst>
       <p:ext uri="{BB962C8B-B14F-4D97-AF65-F5344CB8AC3E}">
-        <p14:creationId xmlns:p14="http://schemas.microsoft.com/office/powerpoint/2010/main" val="62128880"/>
+        <p14:creationId xmlns:p14="http://schemas.microsoft.com/office/powerpoint/2010/main" val="36122720"/>
       </p:ext>
     </p:extLst>
   </p:cSld>
@@ -6836,7 +6836,7 @@
           <p:cNvPr id="16" name="">
             <a:extLst xmlns:a="http://schemas.openxmlformats.org/drawingml/2006/main">
               <a:ext uri="{FF2B5EF4-FFF2-40B4-BE49-F238E27FC236}">
-                <a16:creationId xmlns:a16="http://schemas.microsoft.com/office/drawing/2014/main" id="{0763AF2B-2B9C-445D-BE5F-79705E11BB06}"/>
+                <a16:creationId xmlns:a16="http://schemas.microsoft.com/office/drawing/2014/main" id="{28DD42BB-1B92-46A9-90B6-E5CAEF33DDC9}"/>
               </a:ext>
             </a:extLst>
           </p:cNvPr>
@@ -6894,7 +6894,7 @@
           <p:cNvPr id="2" name="">
             <a:extLst xmlns:a="http://schemas.openxmlformats.org/drawingml/2006/main">
               <a:ext uri="{FF2B5EF4-FFF2-40B4-BE49-F238E27FC236}">
-                <a16:creationId xmlns:a16="http://schemas.microsoft.com/office/drawing/2014/main" id="{F15B7EB9-C085-4B29-8581-04A9169F23CE}"/>
+                <a16:creationId xmlns:a16="http://schemas.microsoft.com/office/drawing/2014/main" id="{DADF5344-FB46-4DD7-BFB1-A73CD2EAD091}"/>
               </a:ext>
             </a:extLst>
           </p:cNvPr>
@@ -6952,7 +6952,7 @@
           <p:cNvPr id="3" name="">
             <a:extLst xmlns:a="http://schemas.openxmlformats.org/drawingml/2006/main">
               <a:ext uri="{FF2B5EF4-FFF2-40B4-BE49-F238E27FC236}">
-                <a16:creationId xmlns:a16="http://schemas.microsoft.com/office/drawing/2014/main" id="{57F77475-FC86-403E-86CE-DCC0AB86F8C3}"/>
+                <a16:creationId xmlns:a16="http://schemas.microsoft.com/office/drawing/2014/main" id="{F91FD8BE-5F5D-416B-831F-EBF829F5ABAD}"/>
               </a:ext>
             </a:extLst>
           </p:cNvPr>
@@ -6983,7 +6983,7 @@
           <p:cNvPr id="4" name="">
             <a:extLst xmlns:a="http://schemas.openxmlformats.org/drawingml/2006/main">
               <a:ext uri="{FF2B5EF4-FFF2-40B4-BE49-F238E27FC236}">
-                <a16:creationId xmlns:a16="http://schemas.microsoft.com/office/drawing/2014/main" id="{1B977933-9197-4EE0-BF07-9A97A46CAB8A}"/>
+                <a16:creationId xmlns:a16="http://schemas.microsoft.com/office/drawing/2014/main" id="{05412929-54C0-4E79-ABF1-675FC68FEB82}"/>
               </a:ext>
             </a:extLst>
           </p:cNvPr>
@@ -7041,7 +7041,7 @@
           <p:cNvPr id="5" name="">
             <a:extLst xmlns:a="http://schemas.openxmlformats.org/drawingml/2006/main">
               <a:ext uri="{FF2B5EF4-FFF2-40B4-BE49-F238E27FC236}">
-                <a16:creationId xmlns:a16="http://schemas.microsoft.com/office/drawing/2014/main" id="{EAE1E40C-DFF3-488F-9776-04CE041A242A}"/>
+                <a16:creationId xmlns:a16="http://schemas.microsoft.com/office/drawing/2014/main" id="{E79BD6EA-77D3-4ED0-A493-58FE28CC5AF6}"/>
               </a:ext>
             </a:extLst>
           </p:cNvPr>
@@ -7099,7 +7099,7 @@
           <p:cNvPr id="6" name="">
             <a:extLst xmlns:a="http://schemas.openxmlformats.org/drawingml/2006/main">
               <a:ext uri="{FF2B5EF4-FFF2-40B4-BE49-F238E27FC236}">
-                <a16:creationId xmlns:a16="http://schemas.microsoft.com/office/drawing/2014/main" id="{8E118ABD-227E-4E14-8573-74CFCBDB38D3}"/>
+                <a16:creationId xmlns:a16="http://schemas.microsoft.com/office/drawing/2014/main" id="{BC1EA847-8B5F-46C0-9FE6-DF5CC4EFE690}"/>
               </a:ext>
             </a:extLst>
           </p:cNvPr>
@@ -7130,7 +7130,7 @@
           <p:cNvPr id="7" name="">
             <a:extLst xmlns:a="http://schemas.openxmlformats.org/drawingml/2006/main">
               <a:ext uri="{FF2B5EF4-FFF2-40B4-BE49-F238E27FC236}">
-                <a16:creationId xmlns:a16="http://schemas.microsoft.com/office/drawing/2014/main" id="{74A0158A-1879-4727-ACC8-86BD514D23B3}"/>
+                <a16:creationId xmlns:a16="http://schemas.microsoft.com/office/drawing/2014/main" id="{7224AE67-443E-4996-BDAB-4CE1D873236D}"/>
               </a:ext>
             </a:extLst>
           </p:cNvPr>
@@ -7188,7 +7188,7 @@
           <p:cNvPr id="8" name="">
             <a:extLst xmlns:a="http://schemas.openxmlformats.org/drawingml/2006/main">
               <a:ext uri="{FF2B5EF4-FFF2-40B4-BE49-F238E27FC236}">
-                <a16:creationId xmlns:a16="http://schemas.microsoft.com/office/drawing/2014/main" id="{018975F8-07EC-4B34-B555-2B8B827EC09D}"/>
+                <a16:creationId xmlns:a16="http://schemas.microsoft.com/office/drawing/2014/main" id="{4C4B2F2F-6ECD-486A-93FF-5D7BF892DEE9}"/>
               </a:ext>
             </a:extLst>
           </p:cNvPr>
@@ -7246,7 +7246,7 @@
           <p:cNvPr id="9" name="">
             <a:extLst xmlns:a="http://schemas.openxmlformats.org/drawingml/2006/main">
               <a:ext uri="{FF2B5EF4-FFF2-40B4-BE49-F238E27FC236}">
-                <a16:creationId xmlns:a16="http://schemas.microsoft.com/office/drawing/2014/main" id="{E5B081A5-9AF7-4FD3-871A-53FAD510AF61}"/>
+                <a16:creationId xmlns:a16="http://schemas.microsoft.com/office/drawing/2014/main" id="{D2ED036D-C711-4704-9211-AF83D9D5468C}"/>
               </a:ext>
             </a:extLst>
           </p:cNvPr>
@@ -7277,7 +7277,7 @@
           <p:cNvPr id="10" name="">
             <a:extLst xmlns:a="http://schemas.openxmlformats.org/drawingml/2006/main">
               <a:ext uri="{FF2B5EF4-FFF2-40B4-BE49-F238E27FC236}">
-                <a16:creationId xmlns:a16="http://schemas.microsoft.com/office/drawing/2014/main" id="{305158B8-8D11-4EEA-96DA-6591ABE8DEAC}"/>
+                <a16:creationId xmlns:a16="http://schemas.microsoft.com/office/drawing/2014/main" id="{32815514-54BA-4BBF-8E04-8B3CA95115D1}"/>
               </a:ext>
             </a:extLst>
           </p:cNvPr>
@@ -7335,7 +7335,7 @@
           <p:cNvPr id="11" name="">
             <a:extLst xmlns:a="http://schemas.openxmlformats.org/drawingml/2006/main">
               <a:ext uri="{FF2B5EF4-FFF2-40B4-BE49-F238E27FC236}">
-                <a16:creationId xmlns:a16="http://schemas.microsoft.com/office/drawing/2014/main" id="{2B7CA124-FDFC-49F3-97A9-B28A2F2068C8}"/>
+                <a16:creationId xmlns:a16="http://schemas.microsoft.com/office/drawing/2014/main" id="{45719A20-29FB-48DE-AAB0-90FCB4F273E9}"/>
               </a:ext>
             </a:extLst>
           </p:cNvPr>
@@ -7393,7 +7393,7 @@
           <p:cNvPr id="12" name="">
             <a:extLst xmlns:a="http://schemas.openxmlformats.org/drawingml/2006/main">
               <a:ext uri="{FF2B5EF4-FFF2-40B4-BE49-F238E27FC236}">
-                <a16:creationId xmlns:a16="http://schemas.microsoft.com/office/drawing/2014/main" id="{A8A353E5-3146-4058-B03B-98572E4D0E36}"/>
+                <a16:creationId xmlns:a16="http://schemas.microsoft.com/office/drawing/2014/main" id="{CDF07394-B173-4216-85AF-752A1064871E}"/>
               </a:ext>
             </a:extLst>
           </p:cNvPr>
@@ -7424,7 +7424,7 @@
           <p:cNvPr id="13" name="">
             <a:extLst xmlns:a="http://schemas.openxmlformats.org/drawingml/2006/main">
               <a:ext uri="{FF2B5EF4-FFF2-40B4-BE49-F238E27FC236}">
-                <a16:creationId xmlns:a16="http://schemas.microsoft.com/office/drawing/2014/main" id="{7649B260-A462-44A1-946E-181946797BA1}"/>
+                <a16:creationId xmlns:a16="http://schemas.microsoft.com/office/drawing/2014/main" id="{CB80005B-99F3-4D1E-AF54-7C8C0D4ABC50}"/>
               </a:ext>
             </a:extLst>
           </p:cNvPr>
@@ -7482,7 +7482,7 @@
           <p:cNvPr id="14" name="">
             <a:extLst xmlns:a="http://schemas.openxmlformats.org/drawingml/2006/main">
               <a:ext uri="{FF2B5EF4-FFF2-40B4-BE49-F238E27FC236}">
-                <a16:creationId xmlns:a16="http://schemas.microsoft.com/office/drawing/2014/main" id="{84532257-6A5A-449D-B623-6307CC3F0BCB}"/>
+                <a16:creationId xmlns:a16="http://schemas.microsoft.com/office/drawing/2014/main" id="{857BD276-B0F2-447D-BE1F-B6E68D8C637A}"/>
               </a:ext>
             </a:extLst>
           </p:cNvPr>
@@ -7540,7 +7540,7 @@
           <p:cNvPr id="15" name="">
             <a:extLst xmlns:a="http://schemas.openxmlformats.org/drawingml/2006/main">
               <a:ext uri="{FF2B5EF4-FFF2-40B4-BE49-F238E27FC236}">
-                <a16:creationId xmlns:a16="http://schemas.microsoft.com/office/drawing/2014/main" id="{A011EDE2-39A9-4CE1-B80B-19A90AFEAB18}"/>
+                <a16:creationId xmlns:a16="http://schemas.microsoft.com/office/drawing/2014/main" id="{F802177A-D1AA-41D8-85FB-0A67785BD254}"/>
               </a:ext>
             </a:extLst>
           </p:cNvPr>
@@ -7596,7 +7596,7 @@
     </p:spTree>
     <p:extLst>
       <p:ext uri="{BB962C8B-B14F-4D97-AF65-F5344CB8AC3E}">
-        <p14:creationId xmlns:p14="http://schemas.microsoft.com/office/powerpoint/2010/main" val="2018695025"/>
+        <p14:creationId xmlns:p14="http://schemas.microsoft.com/office/powerpoint/2010/main" val="328792339"/>
       </p:ext>
     </p:extLst>
   </p:cSld>
@@ -7627,7 +7627,7 @@
           <p:cNvPr id="14" name="">
             <a:extLst xmlns:a="http://schemas.openxmlformats.org/drawingml/2006/main">
               <a:ext uri="{FF2B5EF4-FFF2-40B4-BE49-F238E27FC236}">
-                <a16:creationId xmlns:a16="http://schemas.microsoft.com/office/drawing/2014/main" id="{336316C2-5832-419A-8F00-DD21D1441D80}"/>
+                <a16:creationId xmlns:a16="http://schemas.microsoft.com/office/drawing/2014/main" id="{6B735184-B080-4608-B2A4-3D7FF0201EF3}"/>
               </a:ext>
             </a:extLst>
           </p:cNvPr>
@@ -7685,7 +7685,7 @@
           <p:cNvPr id="2" name="">
             <a:extLst xmlns:a="http://schemas.openxmlformats.org/drawingml/2006/main">
               <a:ext uri="{FF2B5EF4-FFF2-40B4-BE49-F238E27FC236}">
-                <a16:creationId xmlns:a16="http://schemas.microsoft.com/office/drawing/2014/main" id="{C4D552F9-DB63-4547-9113-3B8456E05565}"/>
+                <a16:creationId xmlns:a16="http://schemas.microsoft.com/office/drawing/2014/main" id="{0EEA0CCA-5234-45E7-8607-53451383EDCE}"/>
               </a:ext>
             </a:extLst>
           </p:cNvPr>
@@ -7743,7 +7743,7 @@
           <p:cNvPr id="3" name="">
             <a:extLst xmlns:a="http://schemas.openxmlformats.org/drawingml/2006/main">
               <a:ext uri="{FF2B5EF4-FFF2-40B4-BE49-F238E27FC236}">
-                <a16:creationId xmlns:a16="http://schemas.microsoft.com/office/drawing/2014/main" id="{FBB33AE6-A56F-4E7B-A97C-BA7F6A6AC88D}"/>
+                <a16:creationId xmlns:a16="http://schemas.microsoft.com/office/drawing/2014/main" id="{D9FC8E0F-8DC5-42F3-B763-4379C1D7329A}"/>
               </a:ext>
             </a:extLst>
           </p:cNvPr>
@@ -7774,7 +7774,7 @@
           <p:cNvPr id="4" name="">
             <a:extLst xmlns:a="http://schemas.openxmlformats.org/drawingml/2006/main">
               <a:ext uri="{FF2B5EF4-FFF2-40B4-BE49-F238E27FC236}">
-                <a16:creationId xmlns:a16="http://schemas.microsoft.com/office/drawing/2014/main" id="{736EB82C-9447-4B8C-ABDC-943E37D6969F}"/>
+                <a16:creationId xmlns:a16="http://schemas.microsoft.com/office/drawing/2014/main" id="{8BC3CD23-32DC-4C9D-B2BE-9EF2C5D70D88}"/>
               </a:ext>
             </a:extLst>
           </p:cNvPr>
@@ -7832,7 +7832,7 @@
           <p:cNvPr id="5" name="">
             <a:extLst xmlns:a="http://schemas.openxmlformats.org/drawingml/2006/main">
               <a:ext uri="{FF2B5EF4-FFF2-40B4-BE49-F238E27FC236}">
-                <a16:creationId xmlns:a16="http://schemas.microsoft.com/office/drawing/2014/main" id="{0D59AC5F-7CA9-472C-9FA7-7C69229DC57F}"/>
+                <a16:creationId xmlns:a16="http://schemas.microsoft.com/office/drawing/2014/main" id="{8472669F-C7D3-419F-A3A2-8FB864FB0525}"/>
               </a:ext>
             </a:extLst>
           </p:cNvPr>
@@ -7890,7 +7890,7 @@
           <p:cNvPr id="6" name="">
             <a:extLst xmlns:a="http://schemas.openxmlformats.org/drawingml/2006/main">
               <a:ext uri="{FF2B5EF4-FFF2-40B4-BE49-F238E27FC236}">
-                <a16:creationId xmlns:a16="http://schemas.microsoft.com/office/drawing/2014/main" id="{BC93B37F-7DAD-47A3-ACFB-483ECB21049D}"/>
+                <a16:creationId xmlns:a16="http://schemas.microsoft.com/office/drawing/2014/main" id="{D3ACAF70-C552-4619-8725-524CB94F99CB}"/>
               </a:ext>
             </a:extLst>
           </p:cNvPr>
@@ -7921,7 +7921,7 @@
           <p:cNvPr id="7" name="">
             <a:extLst xmlns:a="http://schemas.openxmlformats.org/drawingml/2006/main">
               <a:ext uri="{FF2B5EF4-FFF2-40B4-BE49-F238E27FC236}">
-                <a16:creationId xmlns:a16="http://schemas.microsoft.com/office/drawing/2014/main" id="{FE84F1A2-757D-4925-8B31-FA93C1620FF9}"/>
+                <a16:creationId xmlns:a16="http://schemas.microsoft.com/office/drawing/2014/main" id="{CBECCAC5-06E5-4FF0-9A78-C45021D27FBC}"/>
               </a:ext>
             </a:extLst>
           </p:cNvPr>
@@ -7952,7 +7952,7 @@
           <p:cNvPr id="8" name="">
             <a:extLst xmlns:a="http://schemas.openxmlformats.org/drawingml/2006/main">
               <a:ext uri="{FF2B5EF4-FFF2-40B4-BE49-F238E27FC236}">
-                <a16:creationId xmlns:a16="http://schemas.microsoft.com/office/drawing/2014/main" id="{F445B089-AEE0-4B54-9B96-4612BB20798E}"/>
+                <a16:creationId xmlns:a16="http://schemas.microsoft.com/office/drawing/2014/main" id="{E4566B14-26F9-4273-9FB8-DD932FFB3B3E}"/>
               </a:ext>
             </a:extLst>
           </p:cNvPr>
@@ -8010,7 +8010,7 @@
           <p:cNvPr id="9" name="">
             <a:extLst xmlns:a="http://schemas.openxmlformats.org/drawingml/2006/main">
               <a:ext uri="{FF2B5EF4-FFF2-40B4-BE49-F238E27FC236}">
-                <a16:creationId xmlns:a16="http://schemas.microsoft.com/office/drawing/2014/main" id="{25D02967-6FBE-4B34-BEFD-E5EF51920168}"/>
+                <a16:creationId xmlns:a16="http://schemas.microsoft.com/office/drawing/2014/main" id="{0FAE1943-AC25-4BB4-B5B2-76830E38CBA7}"/>
               </a:ext>
             </a:extLst>
           </p:cNvPr>
@@ -8114,7 +8114,7 @@
           <p:cNvPr id="10" name="">
             <a:extLst xmlns:a="http://schemas.openxmlformats.org/drawingml/2006/main">
               <a:ext uri="{FF2B5EF4-FFF2-40B4-BE49-F238E27FC236}">
-                <a16:creationId xmlns:a16="http://schemas.microsoft.com/office/drawing/2014/main" id="{CB87D45A-D215-472D-8EFE-4BFD1CA947A6}"/>
+                <a16:creationId xmlns:a16="http://schemas.microsoft.com/office/drawing/2014/main" id="{176DE45B-3AF7-4AB2-BFFA-7CBEC76A0BB4}"/>
               </a:ext>
             </a:extLst>
           </p:cNvPr>
@@ -8172,7 +8172,7 @@
           <p:cNvPr id="11" name="">
             <a:extLst xmlns:a="http://schemas.openxmlformats.org/drawingml/2006/main">
               <a:ext uri="{FF2B5EF4-FFF2-40B4-BE49-F238E27FC236}">
-                <a16:creationId xmlns:a16="http://schemas.microsoft.com/office/drawing/2014/main" id="{293907AE-56AF-43AB-82BD-9D447CD5EF68}"/>
+                <a16:creationId xmlns:a16="http://schemas.microsoft.com/office/drawing/2014/main" id="{40E6D167-FCF0-4150-B0D0-22F4FEA36FE3}"/>
               </a:ext>
             </a:extLst>
           </p:cNvPr>
@@ -8299,7 +8299,7 @@
           <p:cNvPr id="12" name="">
             <a:extLst xmlns:a="http://schemas.openxmlformats.org/drawingml/2006/main">
               <a:ext uri="{FF2B5EF4-FFF2-40B4-BE49-F238E27FC236}">
-                <a16:creationId xmlns:a16="http://schemas.microsoft.com/office/drawing/2014/main" id="{C0377FF3-8A17-4627-8F2C-4A5BBF9FC0AC}"/>
+                <a16:creationId xmlns:a16="http://schemas.microsoft.com/office/drawing/2014/main" id="{4D92347E-F2FB-4CEF-A775-E87224CFA42E}"/>
               </a:ext>
             </a:extLst>
           </p:cNvPr>
@@ -8357,7 +8357,7 @@
           <p:cNvPr id="13" name="">
             <a:extLst xmlns:a="http://schemas.openxmlformats.org/drawingml/2006/main">
               <a:ext uri="{FF2B5EF4-FFF2-40B4-BE49-F238E27FC236}">
-                <a16:creationId xmlns:a16="http://schemas.microsoft.com/office/drawing/2014/main" id="{6D436800-EB4B-4AB8-8FC6-0F639F772DC1}"/>
+                <a16:creationId xmlns:a16="http://schemas.microsoft.com/office/drawing/2014/main" id="{1DA5F283-4A96-4EC9-972B-872E2D93B8AB}"/>
               </a:ext>
             </a:extLst>
           </p:cNvPr>
@@ -8413,7 +8413,7 @@
     </p:spTree>
     <p:extLst>
       <p:ext uri="{BB962C8B-B14F-4D97-AF65-F5344CB8AC3E}">
-        <p14:creationId xmlns:p14="http://schemas.microsoft.com/office/powerpoint/2010/main" val="350926301"/>
+        <p14:creationId xmlns:p14="http://schemas.microsoft.com/office/powerpoint/2010/main" val="77015082"/>
       </p:ext>
     </p:extLst>
   </p:cSld>
@@ -8444,7 +8444,7 @@
           <p:cNvPr id="24" name="">
             <a:extLst xmlns:a="http://schemas.openxmlformats.org/drawingml/2006/main">
               <a:ext uri="{FF2B5EF4-FFF2-40B4-BE49-F238E27FC236}">
-                <a16:creationId xmlns:a16="http://schemas.microsoft.com/office/drawing/2014/main" id="{38C80003-D27E-4D01-99C6-7DE21990CD14}"/>
+                <a16:creationId xmlns:a16="http://schemas.microsoft.com/office/drawing/2014/main" id="{F9AEF812-FC77-4479-B738-1B46FE38BAC5}"/>
               </a:ext>
             </a:extLst>
           </p:cNvPr>
@@ -8502,7 +8502,7 @@
           <p:cNvPr id="2" name="">
             <a:extLst xmlns:a="http://schemas.openxmlformats.org/drawingml/2006/main">
               <a:ext uri="{FF2B5EF4-FFF2-40B4-BE49-F238E27FC236}">
-                <a16:creationId xmlns:a16="http://schemas.microsoft.com/office/drawing/2014/main" id="{5681C207-C449-4BC1-BA00-C9FE2F36DDDA}"/>
+                <a16:creationId xmlns:a16="http://schemas.microsoft.com/office/drawing/2014/main" id="{AFECEFBF-D330-4C49-BA7C-F8C0C2AECF9F}"/>
               </a:ext>
             </a:extLst>
           </p:cNvPr>
@@ -8560,7 +8560,7 @@
           <p:cNvPr id="3" name="">
             <a:extLst xmlns:a="http://schemas.openxmlformats.org/drawingml/2006/main">
               <a:ext uri="{FF2B5EF4-FFF2-40B4-BE49-F238E27FC236}">
-                <a16:creationId xmlns:a16="http://schemas.microsoft.com/office/drawing/2014/main" id="{33C984A8-3524-4AFD-B7D3-5060EF872CAA}"/>
+                <a16:creationId xmlns:a16="http://schemas.microsoft.com/office/drawing/2014/main" id="{03448162-6115-4705-9006-159207853F29}"/>
               </a:ext>
             </a:extLst>
           </p:cNvPr>
@@ -8591,7 +8591,7 @@
           <p:cNvPr id="4" name="">
             <a:extLst xmlns:a="http://schemas.openxmlformats.org/drawingml/2006/main">
               <a:ext uri="{FF2B5EF4-FFF2-40B4-BE49-F238E27FC236}">
-                <a16:creationId xmlns:a16="http://schemas.microsoft.com/office/drawing/2014/main" id="{797F0E9A-0545-40C2-9589-74C6B563905A}"/>
+                <a16:creationId xmlns:a16="http://schemas.microsoft.com/office/drawing/2014/main" id="{92B6321A-0354-43EA-85E2-CFA1C7C60FCF}"/>
               </a:ext>
             </a:extLst>
           </p:cNvPr>
@@ -8649,7 +8649,7 @@
           <p:cNvPr id="5" name="">
             <a:extLst xmlns:a="http://schemas.openxmlformats.org/drawingml/2006/main">
               <a:ext uri="{FF2B5EF4-FFF2-40B4-BE49-F238E27FC236}">
-                <a16:creationId xmlns:a16="http://schemas.microsoft.com/office/drawing/2014/main" id="{16C3217C-0CBC-4BE5-AC2A-38137236BFDB}"/>
+                <a16:creationId xmlns:a16="http://schemas.microsoft.com/office/drawing/2014/main" id="{BB8596A9-1953-4953-8711-22821F4B22F4}"/>
               </a:ext>
             </a:extLst>
           </p:cNvPr>
@@ -8707,7 +8707,7 @@
           <p:cNvPr id="6" name="">
             <a:extLst xmlns:a="http://schemas.openxmlformats.org/drawingml/2006/main">
               <a:ext uri="{FF2B5EF4-FFF2-40B4-BE49-F238E27FC236}">
-                <a16:creationId xmlns:a16="http://schemas.microsoft.com/office/drawing/2014/main" id="{0DDD87C3-66D1-4BE0-90A9-88FD05607543}"/>
+                <a16:creationId xmlns:a16="http://schemas.microsoft.com/office/drawing/2014/main" id="{6699ADD4-E6E6-4166-84B6-535AB5ED58A9}"/>
               </a:ext>
             </a:extLst>
           </p:cNvPr>
@@ -8738,7 +8738,7 @@
           <p:cNvPr id="7" name="">
             <a:extLst xmlns:a="http://schemas.openxmlformats.org/drawingml/2006/main">
               <a:ext uri="{FF2B5EF4-FFF2-40B4-BE49-F238E27FC236}">
-                <a16:creationId xmlns:a16="http://schemas.microsoft.com/office/drawing/2014/main" id="{F6340D50-2D22-46CF-ADA0-3167CFB4B358}"/>
+                <a16:creationId xmlns:a16="http://schemas.microsoft.com/office/drawing/2014/main" id="{A15D631C-F9BE-403D-9A30-BBF42ECC19A3}"/>
               </a:ext>
             </a:extLst>
           </p:cNvPr>
@@ -8769,7 +8769,7 @@
           <p:cNvPr id="8" name="">
             <a:extLst xmlns:a="http://schemas.openxmlformats.org/drawingml/2006/main">
               <a:ext uri="{FF2B5EF4-FFF2-40B4-BE49-F238E27FC236}">
-                <a16:creationId xmlns:a16="http://schemas.microsoft.com/office/drawing/2014/main" id="{F23F1B9F-D9AB-44E2-A0B5-6DD82F3A2517}"/>
+                <a16:creationId xmlns:a16="http://schemas.microsoft.com/office/drawing/2014/main" id="{D9EAF3EB-FEF6-41B2-A864-0B8EDFDCFC1A}"/>
               </a:ext>
             </a:extLst>
           </p:cNvPr>
@@ -8827,7 +8827,7 @@
           <p:cNvPr id="9" name="">
             <a:extLst xmlns:a="http://schemas.openxmlformats.org/drawingml/2006/main">
               <a:ext uri="{FF2B5EF4-FFF2-40B4-BE49-F238E27FC236}">
-                <a16:creationId xmlns:a16="http://schemas.microsoft.com/office/drawing/2014/main" id="{ADB7EB9A-4CAF-4E39-B5F8-3AD6C3789880}"/>
+                <a16:creationId xmlns:a16="http://schemas.microsoft.com/office/drawing/2014/main" id="{3554805F-0A0B-4E53-9E9F-07E334E96137}"/>
               </a:ext>
             </a:extLst>
           </p:cNvPr>
@@ -8885,7 +8885,7 @@
           <p:cNvPr id="10" name="">
             <a:extLst xmlns:a="http://schemas.openxmlformats.org/drawingml/2006/main">
               <a:ext uri="{FF2B5EF4-FFF2-40B4-BE49-F238E27FC236}">
-                <a16:creationId xmlns:a16="http://schemas.microsoft.com/office/drawing/2014/main" id="{CE00876B-4746-489F-AB81-E67D3DF1774D}"/>
+                <a16:creationId xmlns:a16="http://schemas.microsoft.com/office/drawing/2014/main" id="{CCC5C284-8AAD-4F77-851F-132C3336CFD1}"/>
               </a:ext>
             </a:extLst>
           </p:cNvPr>
@@ -8943,7 +8943,7 @@
           <p:cNvPr id="11" name="">
             <a:extLst xmlns:a="http://schemas.openxmlformats.org/drawingml/2006/main">
               <a:ext uri="{FF2B5EF4-FFF2-40B4-BE49-F238E27FC236}">
-                <a16:creationId xmlns:a16="http://schemas.microsoft.com/office/drawing/2014/main" id="{B29089D1-B762-48D8-9070-F88BFE026060}"/>
+                <a16:creationId xmlns:a16="http://schemas.microsoft.com/office/drawing/2014/main" id="{2389BB1C-2551-42A7-B5E0-DCAD081AE51D}"/>
               </a:ext>
             </a:extLst>
           </p:cNvPr>
@@ -8974,7 +8974,7 @@
           <p:cNvPr id="12" name="">
             <a:extLst xmlns:a="http://schemas.openxmlformats.org/drawingml/2006/main">
               <a:ext uri="{FF2B5EF4-FFF2-40B4-BE49-F238E27FC236}">
-                <a16:creationId xmlns:a16="http://schemas.microsoft.com/office/drawing/2014/main" id="{258D28D3-1823-43DA-977C-F66C95327775}"/>
+                <a16:creationId xmlns:a16="http://schemas.microsoft.com/office/drawing/2014/main" id="{A64469E0-1837-497D-8CD9-4B34FDD9CEE1}"/>
               </a:ext>
             </a:extLst>
           </p:cNvPr>
@@ -9032,7 +9032,7 @@
           <p:cNvPr id="13" name="">
             <a:extLst xmlns:a="http://schemas.openxmlformats.org/drawingml/2006/main">
               <a:ext uri="{FF2B5EF4-FFF2-40B4-BE49-F238E27FC236}">
-                <a16:creationId xmlns:a16="http://schemas.microsoft.com/office/drawing/2014/main" id="{ABD3F8B0-5EAA-4D50-B0C5-3F9526D4F068}"/>
+                <a16:creationId xmlns:a16="http://schemas.microsoft.com/office/drawing/2014/main" id="{074D9871-C406-4593-870A-F45E69D2F7E6}"/>
               </a:ext>
             </a:extLst>
           </p:cNvPr>
@@ -9090,7 +9090,7 @@
           <p:cNvPr id="14" name="">
             <a:extLst xmlns:a="http://schemas.openxmlformats.org/drawingml/2006/main">
               <a:ext uri="{FF2B5EF4-FFF2-40B4-BE49-F238E27FC236}">
-                <a16:creationId xmlns:a16="http://schemas.microsoft.com/office/drawing/2014/main" id="{54B06D27-A3C7-4FF2-8DE3-8A1DE400A34F}"/>
+                <a16:creationId xmlns:a16="http://schemas.microsoft.com/office/drawing/2014/main" id="{F1BD3DBF-BAF1-4776-91F7-6F0BE3304731}"/>
               </a:ext>
             </a:extLst>
           </p:cNvPr>
@@ -9148,7 +9148,7 @@
           <p:cNvPr id="15" name="">
             <a:extLst xmlns:a="http://schemas.openxmlformats.org/drawingml/2006/main">
               <a:ext uri="{FF2B5EF4-FFF2-40B4-BE49-F238E27FC236}">
-                <a16:creationId xmlns:a16="http://schemas.microsoft.com/office/drawing/2014/main" id="{ADD40CB6-21E1-4A98-A15D-AEAD1C3597FB}"/>
+                <a16:creationId xmlns:a16="http://schemas.microsoft.com/office/drawing/2014/main" id="{4D7A3410-E5CA-44EE-8CE4-FCE2A997DEE4}"/>
               </a:ext>
             </a:extLst>
           </p:cNvPr>
@@ -9179,7 +9179,7 @@
           <p:cNvPr id="16" name="">
             <a:extLst xmlns:a="http://schemas.openxmlformats.org/drawingml/2006/main">
               <a:ext uri="{FF2B5EF4-FFF2-40B4-BE49-F238E27FC236}">
-                <a16:creationId xmlns:a16="http://schemas.microsoft.com/office/drawing/2014/main" id="{F51614F9-84A8-491A-AA3E-1B1C6AF9F9C7}"/>
+                <a16:creationId xmlns:a16="http://schemas.microsoft.com/office/drawing/2014/main" id="{6D700DE8-B58B-449C-A858-2871BDF2FFB9}"/>
               </a:ext>
             </a:extLst>
           </p:cNvPr>
@@ -9237,7 +9237,7 @@
           <p:cNvPr id="17" name="">
             <a:extLst xmlns:a="http://schemas.openxmlformats.org/drawingml/2006/main">
               <a:ext uri="{FF2B5EF4-FFF2-40B4-BE49-F238E27FC236}">
-                <a16:creationId xmlns:a16="http://schemas.microsoft.com/office/drawing/2014/main" id="{BD2561D1-D65D-4D7A-9041-B68A70BE4C36}"/>
+                <a16:creationId xmlns:a16="http://schemas.microsoft.com/office/drawing/2014/main" id="{CA5AF6A3-08E2-4209-86CC-465C3101FF43}"/>
               </a:ext>
             </a:extLst>
           </p:cNvPr>
@@ -9295,7 +9295,7 @@
           <p:cNvPr id="18" name="">
             <a:extLst xmlns:a="http://schemas.openxmlformats.org/drawingml/2006/main">
               <a:ext uri="{FF2B5EF4-FFF2-40B4-BE49-F238E27FC236}">
-                <a16:creationId xmlns:a16="http://schemas.microsoft.com/office/drawing/2014/main" id="{879561C7-98E9-4CE4-8291-53B42CCD13F1}"/>
+                <a16:creationId xmlns:a16="http://schemas.microsoft.com/office/drawing/2014/main" id="{13690A36-7D31-403D-BEC7-5FAE518B1BDE}"/>
               </a:ext>
             </a:extLst>
           </p:cNvPr>
@@ -9353,7 +9353,7 @@
           <p:cNvPr id="19" name="">
             <a:extLst xmlns:a="http://schemas.openxmlformats.org/drawingml/2006/main">
               <a:ext uri="{FF2B5EF4-FFF2-40B4-BE49-F238E27FC236}">
-                <a16:creationId xmlns:a16="http://schemas.microsoft.com/office/drawing/2014/main" id="{58FBC30C-6F75-4144-A51C-951FEF4EDE7E}"/>
+                <a16:creationId xmlns:a16="http://schemas.microsoft.com/office/drawing/2014/main" id="{08F94462-9677-446E-9CAD-DF9D477F4782}"/>
               </a:ext>
             </a:extLst>
           </p:cNvPr>
@@ -9384,7 +9384,7 @@
           <p:cNvPr id="20" name="">
             <a:extLst xmlns:a="http://schemas.openxmlformats.org/drawingml/2006/main">
               <a:ext uri="{FF2B5EF4-FFF2-40B4-BE49-F238E27FC236}">
-                <a16:creationId xmlns:a16="http://schemas.microsoft.com/office/drawing/2014/main" id="{9ECE073D-74E1-49C0-B992-6CEA02FFCC52}"/>
+                <a16:creationId xmlns:a16="http://schemas.microsoft.com/office/drawing/2014/main" id="{C0CB4F3C-D10C-4E1F-B037-241EEAE74929}"/>
               </a:ext>
             </a:extLst>
           </p:cNvPr>
@@ -9442,7 +9442,7 @@
           <p:cNvPr id="21" name="">
             <a:extLst xmlns:a="http://schemas.openxmlformats.org/drawingml/2006/main">
               <a:ext uri="{FF2B5EF4-FFF2-40B4-BE49-F238E27FC236}">
-                <a16:creationId xmlns:a16="http://schemas.microsoft.com/office/drawing/2014/main" id="{2A2119DB-B2AD-4F02-813E-6C144B71F601}"/>
+                <a16:creationId xmlns:a16="http://schemas.microsoft.com/office/drawing/2014/main" id="{7564FE55-3CEC-462C-99C3-DECC15230D38}"/>
               </a:ext>
             </a:extLst>
           </p:cNvPr>
@@ -9500,7 +9500,7 @@
           <p:cNvPr id="22" name="">
             <a:extLst xmlns:a="http://schemas.openxmlformats.org/drawingml/2006/main">
               <a:ext uri="{FF2B5EF4-FFF2-40B4-BE49-F238E27FC236}">
-                <a16:creationId xmlns:a16="http://schemas.microsoft.com/office/drawing/2014/main" id="{F227CA22-C7D0-43AF-860F-06BC7A2099C3}"/>
+                <a16:creationId xmlns:a16="http://schemas.microsoft.com/office/drawing/2014/main" id="{1806A5F7-76E8-48B7-A368-F1A8103C1210}"/>
               </a:ext>
             </a:extLst>
           </p:cNvPr>
@@ -9558,7 +9558,7 @@
           <p:cNvPr id="23" name="">
             <a:extLst xmlns:a="http://schemas.openxmlformats.org/drawingml/2006/main">
               <a:ext uri="{FF2B5EF4-FFF2-40B4-BE49-F238E27FC236}">
-                <a16:creationId xmlns:a16="http://schemas.microsoft.com/office/drawing/2014/main" id="{FD71DE1F-D8C1-40E2-8AA2-191CD5F6D25E}"/>
+                <a16:creationId xmlns:a16="http://schemas.microsoft.com/office/drawing/2014/main" id="{7E08A6B9-E866-4D59-8EE3-930A218C9815}"/>
               </a:ext>
             </a:extLst>
           </p:cNvPr>
@@ -9614,7 +9614,7 @@
     </p:spTree>
     <p:extLst>
       <p:ext uri="{BB962C8B-B14F-4D97-AF65-F5344CB8AC3E}">
-        <p14:creationId xmlns:p14="http://schemas.microsoft.com/office/powerpoint/2010/main" val="842086588"/>
+        <p14:creationId xmlns:p14="http://schemas.microsoft.com/office/powerpoint/2010/main" val="1647954921"/>
       </p:ext>
     </p:extLst>
   </p:cSld>
@@ -9645,7 +9645,7 @@
           <p:cNvPr id="21" name="">
             <a:extLst xmlns:a="http://schemas.openxmlformats.org/drawingml/2006/main">
               <a:ext uri="{FF2B5EF4-FFF2-40B4-BE49-F238E27FC236}">
-                <a16:creationId xmlns:a16="http://schemas.microsoft.com/office/drawing/2014/main" id="{73EAF029-B017-4F11-B325-4B654667BB73}"/>
+                <a16:creationId xmlns:a16="http://schemas.microsoft.com/office/drawing/2014/main" id="{018BB7B1-CCA1-4641-8C03-D388013B9EEE}"/>
               </a:ext>
             </a:extLst>
           </p:cNvPr>
@@ -9703,7 +9703,7 @@
           <p:cNvPr id="2" name="">
             <a:extLst xmlns:a="http://schemas.openxmlformats.org/drawingml/2006/main">
               <a:ext uri="{FF2B5EF4-FFF2-40B4-BE49-F238E27FC236}">
-                <a16:creationId xmlns:a16="http://schemas.microsoft.com/office/drawing/2014/main" id="{2BB49AA2-795C-471A-8789-F8E38419D934}"/>
+                <a16:creationId xmlns:a16="http://schemas.microsoft.com/office/drawing/2014/main" id="{E7B84B41-C38F-4C03-A7AB-B9C039DD41DC}"/>
               </a:ext>
             </a:extLst>
           </p:cNvPr>
@@ -9761,7 +9761,7 @@
           <p:cNvPr id="3" name="">
             <a:extLst xmlns:a="http://schemas.openxmlformats.org/drawingml/2006/main">
               <a:ext uri="{FF2B5EF4-FFF2-40B4-BE49-F238E27FC236}">
-                <a16:creationId xmlns:a16="http://schemas.microsoft.com/office/drawing/2014/main" id="{0A9E51A2-FE36-4841-9FF6-C097C3C1E887}"/>
+                <a16:creationId xmlns:a16="http://schemas.microsoft.com/office/drawing/2014/main" id="{5ED0D2FB-058C-4856-90B2-077B5F08F5A1}"/>
               </a:ext>
             </a:extLst>
           </p:cNvPr>
@@ -9792,7 +9792,7 @@
           <p:cNvPr id="4" name="">
             <a:extLst xmlns:a="http://schemas.openxmlformats.org/drawingml/2006/main">
               <a:ext uri="{FF2B5EF4-FFF2-40B4-BE49-F238E27FC236}">
-                <a16:creationId xmlns:a16="http://schemas.microsoft.com/office/drawing/2014/main" id="{0F14400B-ECE8-4B13-BE94-C538FAA8FAE5}"/>
+                <a16:creationId xmlns:a16="http://schemas.microsoft.com/office/drawing/2014/main" id="{2406BF3B-A606-4A81-93A3-2CAF6228F38D}"/>
               </a:ext>
             </a:extLst>
           </p:cNvPr>
@@ -9850,7 +9850,7 @@
           <p:cNvPr id="5" name="">
             <a:extLst xmlns:a="http://schemas.openxmlformats.org/drawingml/2006/main">
               <a:ext uri="{FF2B5EF4-FFF2-40B4-BE49-F238E27FC236}">
-                <a16:creationId xmlns:a16="http://schemas.microsoft.com/office/drawing/2014/main" id="{85B6C639-B90A-4C09-9A0C-4F5BECE47D32}"/>
+                <a16:creationId xmlns:a16="http://schemas.microsoft.com/office/drawing/2014/main" id="{21E96A50-0FD0-44EC-AA67-E721D8D0A2AD}"/>
               </a:ext>
             </a:extLst>
           </p:cNvPr>
@@ -9908,7 +9908,7 @@
           <p:cNvPr id="6" name="">
             <a:extLst xmlns:a="http://schemas.openxmlformats.org/drawingml/2006/main">
               <a:ext uri="{FF2B5EF4-FFF2-40B4-BE49-F238E27FC236}">
-                <a16:creationId xmlns:a16="http://schemas.microsoft.com/office/drawing/2014/main" id="{E4B172B3-7A78-41D6-B036-6B073BAD2608}"/>
+                <a16:creationId xmlns:a16="http://schemas.microsoft.com/office/drawing/2014/main" id="{5A244F03-44C1-4BDA-88D0-05B9BF1E2B91}"/>
               </a:ext>
             </a:extLst>
           </p:cNvPr>
@@ -9939,7 +9939,7 @@
           <p:cNvPr id="7" name="">
             <a:extLst xmlns:a="http://schemas.openxmlformats.org/drawingml/2006/main">
               <a:ext uri="{FF2B5EF4-FFF2-40B4-BE49-F238E27FC236}">
-                <a16:creationId xmlns:a16="http://schemas.microsoft.com/office/drawing/2014/main" id="{ED2550AC-F5DF-4E83-8054-00CE7599C17D}"/>
+                <a16:creationId xmlns:a16="http://schemas.microsoft.com/office/drawing/2014/main" id="{8E3EC58C-6F3E-45D6-807A-A5E5ECF95693}"/>
               </a:ext>
             </a:extLst>
           </p:cNvPr>
@@ -9997,7 +9997,7 @@
           <p:cNvPr id="8" name="">
             <a:extLst xmlns:a="http://schemas.openxmlformats.org/drawingml/2006/main">
               <a:ext uri="{FF2B5EF4-FFF2-40B4-BE49-F238E27FC236}">
-                <a16:creationId xmlns:a16="http://schemas.microsoft.com/office/drawing/2014/main" id="{72BE60FF-DF97-469B-8C67-5E00022C2CA4}"/>
+                <a16:creationId xmlns:a16="http://schemas.microsoft.com/office/drawing/2014/main" id="{739941C6-E60A-4311-A32B-20E481B682C6}"/>
               </a:ext>
             </a:extLst>
           </p:cNvPr>
@@ -10055,7 +10055,7 @@
           <p:cNvPr id="9" name="">
             <a:extLst xmlns:a="http://schemas.openxmlformats.org/drawingml/2006/main">
               <a:ext uri="{FF2B5EF4-FFF2-40B4-BE49-F238E27FC236}">
-                <a16:creationId xmlns:a16="http://schemas.microsoft.com/office/drawing/2014/main" id="{13B1F40F-91D2-40EA-9CBC-61D2765FA93B}"/>
+                <a16:creationId xmlns:a16="http://schemas.microsoft.com/office/drawing/2014/main" id="{6ACE66D4-AD61-44C4-936F-7F57F0B56044}"/>
               </a:ext>
             </a:extLst>
           </p:cNvPr>
@@ -10113,7 +10113,7 @@
           <p:cNvPr id="10" name="">
             <a:extLst xmlns:a="http://schemas.openxmlformats.org/drawingml/2006/main">
               <a:ext uri="{FF2B5EF4-FFF2-40B4-BE49-F238E27FC236}">
-                <a16:creationId xmlns:a16="http://schemas.microsoft.com/office/drawing/2014/main" id="{CBDA89CF-F64D-4087-8916-2B8816601749}"/>
+                <a16:creationId xmlns:a16="http://schemas.microsoft.com/office/drawing/2014/main" id="{479DD112-56C5-47CA-83CB-05BC80B68B40}"/>
               </a:ext>
             </a:extLst>
           </p:cNvPr>
@@ -10171,7 +10171,7 @@
           <p:cNvPr id="11" name="">
             <a:extLst xmlns:a="http://schemas.openxmlformats.org/drawingml/2006/main">
               <a:ext uri="{FF2B5EF4-FFF2-40B4-BE49-F238E27FC236}">
-                <a16:creationId xmlns:a16="http://schemas.microsoft.com/office/drawing/2014/main" id="{2FBC8C9C-CFD6-468A-BC76-D393AE08176F}"/>
+                <a16:creationId xmlns:a16="http://schemas.microsoft.com/office/drawing/2014/main" id="{50D5335E-C1EE-4A57-9E96-EE1E15D89073}"/>
               </a:ext>
             </a:extLst>
           </p:cNvPr>
@@ -10229,7 +10229,7 @@
           <p:cNvPr id="12" name="">
             <a:extLst xmlns:a="http://schemas.openxmlformats.org/drawingml/2006/main">
               <a:ext uri="{FF2B5EF4-FFF2-40B4-BE49-F238E27FC236}">
-                <a16:creationId xmlns:a16="http://schemas.microsoft.com/office/drawing/2014/main" id="{3F6CE553-885C-4462-B7B9-3139A6CE3784}"/>
+                <a16:creationId xmlns:a16="http://schemas.microsoft.com/office/drawing/2014/main" id="{605E8BA7-60CE-413A-8349-6D852142A4E7}"/>
               </a:ext>
             </a:extLst>
           </p:cNvPr>
@@ -10287,7 +10287,7 @@
           <p:cNvPr id="13" name="">
             <a:extLst xmlns:a="http://schemas.openxmlformats.org/drawingml/2006/main">
               <a:ext uri="{FF2B5EF4-FFF2-40B4-BE49-F238E27FC236}">
-                <a16:creationId xmlns:a16="http://schemas.microsoft.com/office/drawing/2014/main" id="{229F4268-AEB4-4CD1-B4B4-92BE6F261D95}"/>
+                <a16:creationId xmlns:a16="http://schemas.microsoft.com/office/drawing/2014/main" id="{A7857F45-62DB-4903-9AA3-E88DA13EE24D}"/>
               </a:ext>
             </a:extLst>
           </p:cNvPr>
@@ -10318,7 +10318,7 @@
           <p:cNvPr id="14" name="">
             <a:extLst xmlns:a="http://schemas.openxmlformats.org/drawingml/2006/main">
               <a:ext uri="{FF2B5EF4-FFF2-40B4-BE49-F238E27FC236}">
-                <a16:creationId xmlns:a16="http://schemas.microsoft.com/office/drawing/2014/main" id="{3A2FB3B3-B9CD-4E93-AAAF-CE817A0CFCE3}"/>
+                <a16:creationId xmlns:a16="http://schemas.microsoft.com/office/drawing/2014/main" id="{EBCE907A-25A0-46BE-B874-24CA00B28118}"/>
               </a:ext>
             </a:extLst>
           </p:cNvPr>
@@ -10376,7 +10376,7 @@
           <p:cNvPr id="15" name="">
             <a:extLst xmlns:a="http://schemas.openxmlformats.org/drawingml/2006/main">
               <a:ext uri="{FF2B5EF4-FFF2-40B4-BE49-F238E27FC236}">
-                <a16:creationId xmlns:a16="http://schemas.microsoft.com/office/drawing/2014/main" id="{0FBBCEFE-2D3E-401E-9A0D-1426B821D2C2}"/>
+                <a16:creationId xmlns:a16="http://schemas.microsoft.com/office/drawing/2014/main" id="{040255A8-BF38-4247-B64C-D3ECCEB5246B}"/>
               </a:ext>
             </a:extLst>
           </p:cNvPr>
@@ -10434,7 +10434,7 @@
           <p:cNvPr id="16" name="">
             <a:extLst xmlns:a="http://schemas.openxmlformats.org/drawingml/2006/main">
               <a:ext uri="{FF2B5EF4-FFF2-40B4-BE49-F238E27FC236}">
-                <a16:creationId xmlns:a16="http://schemas.microsoft.com/office/drawing/2014/main" id="{5014D90A-5CBD-4AB4-BD54-A8A93C2EB3F9}"/>
+                <a16:creationId xmlns:a16="http://schemas.microsoft.com/office/drawing/2014/main" id="{047F4100-E560-4493-B02A-B86143CE8207}"/>
               </a:ext>
             </a:extLst>
           </p:cNvPr>
@@ -10492,7 +10492,7 @@
           <p:cNvPr id="17" name="">
             <a:extLst xmlns:a="http://schemas.openxmlformats.org/drawingml/2006/main">
               <a:ext uri="{FF2B5EF4-FFF2-40B4-BE49-F238E27FC236}">
-                <a16:creationId xmlns:a16="http://schemas.microsoft.com/office/drawing/2014/main" id="{54C30C29-786B-45EA-812F-E74370F7FDED}"/>
+                <a16:creationId xmlns:a16="http://schemas.microsoft.com/office/drawing/2014/main" id="{AC30EACA-A4D5-4601-90A0-A04AD39630D8}"/>
               </a:ext>
             </a:extLst>
           </p:cNvPr>
@@ -10550,7 +10550,7 @@
           <p:cNvPr id="18" name="">
             <a:extLst xmlns:a="http://schemas.openxmlformats.org/drawingml/2006/main">
               <a:ext uri="{FF2B5EF4-FFF2-40B4-BE49-F238E27FC236}">
-                <a16:creationId xmlns:a16="http://schemas.microsoft.com/office/drawing/2014/main" id="{5145ECC0-DC22-4525-BAD2-06378F2EA5C8}"/>
+                <a16:creationId xmlns:a16="http://schemas.microsoft.com/office/drawing/2014/main" id="{5E3F28EB-32AC-4487-A8A1-70CCA0C559A4}"/>
               </a:ext>
             </a:extLst>
           </p:cNvPr>
@@ -10608,7 +10608,7 @@
           <p:cNvPr id="19" name="">
             <a:extLst xmlns:a="http://schemas.openxmlformats.org/drawingml/2006/main">
               <a:ext uri="{FF2B5EF4-FFF2-40B4-BE49-F238E27FC236}">
-                <a16:creationId xmlns:a16="http://schemas.microsoft.com/office/drawing/2014/main" id="{E74E6A3C-A164-4921-AEBB-ED2552BB1E06}"/>
+                <a16:creationId xmlns:a16="http://schemas.microsoft.com/office/drawing/2014/main" id="{9F7ACA60-E722-492E-AAB2-2B093336966E}"/>
               </a:ext>
             </a:extLst>
           </p:cNvPr>
@@ -10666,7 +10666,7 @@
           <p:cNvPr id="20" name="">
             <a:extLst xmlns:a="http://schemas.openxmlformats.org/drawingml/2006/main">
               <a:ext uri="{FF2B5EF4-FFF2-40B4-BE49-F238E27FC236}">
-                <a16:creationId xmlns:a16="http://schemas.microsoft.com/office/drawing/2014/main" id="{3424EF36-0CFF-43A9-B377-BE9F222C7C3B}"/>
+                <a16:creationId xmlns:a16="http://schemas.microsoft.com/office/drawing/2014/main" id="{FD1B01FF-1E44-4FF6-BB05-8ED1A5EC5609}"/>
               </a:ext>
             </a:extLst>
           </p:cNvPr>
@@ -10722,7 +10722,7 @@
     </p:spTree>
     <p:extLst>
       <p:ext uri="{BB962C8B-B14F-4D97-AF65-F5344CB8AC3E}">
-        <p14:creationId xmlns:p14="http://schemas.microsoft.com/office/powerpoint/2010/main" val="428804222"/>
+        <p14:creationId xmlns:p14="http://schemas.microsoft.com/office/powerpoint/2010/main" val="252572371"/>
       </p:ext>
     </p:extLst>
   </p:cSld>
@@ -10753,7 +10753,7 @@
           <p:cNvPr id="19" name="">
             <a:extLst xmlns:a="http://schemas.openxmlformats.org/drawingml/2006/main">
               <a:ext uri="{FF2B5EF4-FFF2-40B4-BE49-F238E27FC236}">
-                <a16:creationId xmlns:a16="http://schemas.microsoft.com/office/drawing/2014/main" id="{3A972441-0018-485E-B006-172958A6EE85}"/>
+                <a16:creationId xmlns:a16="http://schemas.microsoft.com/office/drawing/2014/main" id="{09CE6154-9EA5-45B1-96C5-B13D401770DE}"/>
               </a:ext>
             </a:extLst>
           </p:cNvPr>
@@ -10811,7 +10811,7 @@
           <p:cNvPr id="2" name="">
             <a:extLst xmlns:a="http://schemas.openxmlformats.org/drawingml/2006/main">
               <a:ext uri="{FF2B5EF4-FFF2-40B4-BE49-F238E27FC236}">
-                <a16:creationId xmlns:a16="http://schemas.microsoft.com/office/drawing/2014/main" id="{14302B5E-6475-4165-8014-46AB2D5B7EBE}"/>
+                <a16:creationId xmlns:a16="http://schemas.microsoft.com/office/drawing/2014/main" id="{EDBE1180-085C-470C-84D9-0F8F5222B5E9}"/>
               </a:ext>
             </a:extLst>
           </p:cNvPr>
@@ -10869,7 +10869,7 @@
           <p:cNvPr id="3" name="">
             <a:extLst xmlns:a="http://schemas.openxmlformats.org/drawingml/2006/main">
               <a:ext uri="{FF2B5EF4-FFF2-40B4-BE49-F238E27FC236}">
-                <a16:creationId xmlns:a16="http://schemas.microsoft.com/office/drawing/2014/main" id="{E9D43D65-0984-4757-A503-E075ABE0DC83}"/>
+                <a16:creationId xmlns:a16="http://schemas.microsoft.com/office/drawing/2014/main" id="{DA71DA5E-C9B5-4FE7-AE31-A1EABBA77DA9}"/>
               </a:ext>
             </a:extLst>
           </p:cNvPr>
@@ -10900,7 +10900,7 @@
           <p:cNvPr id="4" name="">
             <a:extLst xmlns:a="http://schemas.openxmlformats.org/drawingml/2006/main">
               <a:ext uri="{FF2B5EF4-FFF2-40B4-BE49-F238E27FC236}">
-                <a16:creationId xmlns:a16="http://schemas.microsoft.com/office/drawing/2014/main" id="{C1E3D83A-B430-4AA4-9FCC-C5E52D58071F}"/>
+                <a16:creationId xmlns:a16="http://schemas.microsoft.com/office/drawing/2014/main" id="{658018EC-A76E-4941-8D22-48A288259316}"/>
               </a:ext>
             </a:extLst>
           </p:cNvPr>
@@ -10958,7 +10958,7 @@
           <p:cNvPr id="5" name="">
             <a:extLst xmlns:a="http://schemas.openxmlformats.org/drawingml/2006/main">
               <a:ext uri="{FF2B5EF4-FFF2-40B4-BE49-F238E27FC236}">
-                <a16:creationId xmlns:a16="http://schemas.microsoft.com/office/drawing/2014/main" id="{BBE0A10D-AF73-4578-BC00-4E8AE711B916}"/>
+                <a16:creationId xmlns:a16="http://schemas.microsoft.com/office/drawing/2014/main" id="{CC2DB056-4B16-4379-B18F-763224C0382C}"/>
               </a:ext>
             </a:extLst>
           </p:cNvPr>
@@ -11006,7 +11006,7 @@
                 <a:ea typeface="Helvetica Neue"/>
                 <a:cs typeface="Helvetica Neue"/>
               </a:rPr>
-              <a:t>The first customer is a team using several coding agents or worktrees against the same active repository.</a:t>
+              <a:t>First customer: a team already running several agents or worktrees in one active repository.</a:t>
             </a:r>
           </a:p>
         </p:txBody>
@@ -11016,7 +11016,7 @@
           <p:cNvPr id="6" name="">
             <a:extLst xmlns:a="http://schemas.openxmlformats.org/drawingml/2006/main">
               <a:ext uri="{FF2B5EF4-FFF2-40B4-BE49-F238E27FC236}">
-                <a16:creationId xmlns:a16="http://schemas.microsoft.com/office/drawing/2014/main" id="{317AF3BC-3EB6-4760-A6EF-0E2F02B5B63C}"/>
+                <a16:creationId xmlns:a16="http://schemas.microsoft.com/office/drawing/2014/main" id="{89684D79-5262-4BAC-8686-6853CB695235}"/>
               </a:ext>
             </a:extLst>
           </p:cNvPr>
@@ -11074,7 +11074,7 @@
           <p:cNvPr id="7" name="">
             <a:extLst xmlns:a="http://schemas.openxmlformats.org/drawingml/2006/main">
               <a:ext uri="{FF2B5EF4-FFF2-40B4-BE49-F238E27FC236}">
-                <a16:creationId xmlns:a16="http://schemas.microsoft.com/office/drawing/2014/main" id="{60F048E5-274F-4EA9-B1D5-D78EE07B9AC3}"/>
+                <a16:creationId xmlns:a16="http://schemas.microsoft.com/office/drawing/2014/main" id="{6D9F98CD-1440-46F6-AA93-D94F793BE36B}"/>
               </a:ext>
             </a:extLst>
           </p:cNvPr>
@@ -11132,7 +11132,7 @@
           <p:cNvPr id="8" name="">
             <a:extLst xmlns:a="http://schemas.openxmlformats.org/drawingml/2006/main">
               <a:ext uri="{FF2B5EF4-FFF2-40B4-BE49-F238E27FC236}">
-                <a16:creationId xmlns:a16="http://schemas.microsoft.com/office/drawing/2014/main" id="{8EA6AEC1-EC9E-4872-986F-4DCE3A42267B}"/>
+                <a16:creationId xmlns:a16="http://schemas.microsoft.com/office/drawing/2014/main" id="{95306F22-3ED6-4CB4-9689-B1C93946CF93}"/>
               </a:ext>
             </a:extLst>
           </p:cNvPr>
@@ -11190,7 +11190,7 @@
           <p:cNvPr id="9" name="">
             <a:extLst xmlns:a="http://schemas.openxmlformats.org/drawingml/2006/main">
               <a:ext uri="{FF2B5EF4-FFF2-40B4-BE49-F238E27FC236}">
-                <a16:creationId xmlns:a16="http://schemas.microsoft.com/office/drawing/2014/main" id="{FFA1DBA4-FC38-4008-BE8C-D37CA5A67DCA}"/>
+                <a16:creationId xmlns:a16="http://schemas.microsoft.com/office/drawing/2014/main" id="{EA09E259-3087-4018-B147-A2988E8D1AEE}"/>
               </a:ext>
             </a:extLst>
           </p:cNvPr>
@@ -11221,7 +11221,7 @@
           <p:cNvPr id="10" name="">
             <a:extLst xmlns:a="http://schemas.openxmlformats.org/drawingml/2006/main">
               <a:ext uri="{FF2B5EF4-FFF2-40B4-BE49-F238E27FC236}">
-                <a16:creationId xmlns:a16="http://schemas.microsoft.com/office/drawing/2014/main" id="{3487A5FC-4D83-4BB1-8B1C-4F850034731B}"/>
+                <a16:creationId xmlns:a16="http://schemas.microsoft.com/office/drawing/2014/main" id="{29D1AF42-E8B9-4F2D-8F3E-38071DD509AE}"/>
               </a:ext>
             </a:extLst>
           </p:cNvPr>
@@ -11279,7 +11279,7 @@
           <p:cNvPr id="11" name="">
             <a:extLst xmlns:a="http://schemas.openxmlformats.org/drawingml/2006/main">
               <a:ext uri="{FF2B5EF4-FFF2-40B4-BE49-F238E27FC236}">
-                <a16:creationId xmlns:a16="http://schemas.microsoft.com/office/drawing/2014/main" id="{0F27E32D-0D22-4EC2-A856-CC75274B329A}"/>
+                <a16:creationId xmlns:a16="http://schemas.microsoft.com/office/drawing/2014/main" id="{06614707-468A-404C-81D9-CA21303E0622}"/>
               </a:ext>
             </a:extLst>
           </p:cNvPr>
@@ -11337,7 +11337,7 @@
           <p:cNvPr id="12" name="">
             <a:extLst xmlns:a="http://schemas.openxmlformats.org/drawingml/2006/main">
               <a:ext uri="{FF2B5EF4-FFF2-40B4-BE49-F238E27FC236}">
-                <a16:creationId xmlns:a16="http://schemas.microsoft.com/office/drawing/2014/main" id="{7DCFE866-5EFC-4085-B4DC-A414A897FEFA}"/>
+                <a16:creationId xmlns:a16="http://schemas.microsoft.com/office/drawing/2014/main" id="{FEAFA2D8-2E1B-430F-B7E9-931DB00E4552}"/>
               </a:ext>
             </a:extLst>
           </p:cNvPr>
@@ -11395,7 +11395,7 @@
           <p:cNvPr id="13" name="">
             <a:extLst xmlns:a="http://schemas.openxmlformats.org/drawingml/2006/main">
               <a:ext uri="{FF2B5EF4-FFF2-40B4-BE49-F238E27FC236}">
-                <a16:creationId xmlns:a16="http://schemas.microsoft.com/office/drawing/2014/main" id="{A48FF425-7555-4620-A9DE-6AA78853FC0D}"/>
+                <a16:creationId xmlns:a16="http://schemas.microsoft.com/office/drawing/2014/main" id="{507B93E8-4DFD-4BB2-88A9-06FEB4432E52}"/>
               </a:ext>
             </a:extLst>
           </p:cNvPr>
@@ -11426,7 +11426,7 @@
           <p:cNvPr id="14" name="">
             <a:extLst xmlns:a="http://schemas.openxmlformats.org/drawingml/2006/main">
               <a:ext uri="{FF2B5EF4-FFF2-40B4-BE49-F238E27FC236}">
-                <a16:creationId xmlns:a16="http://schemas.microsoft.com/office/drawing/2014/main" id="{72E7C23E-1401-4F65-B929-C289AFFD03F7}"/>
+                <a16:creationId xmlns:a16="http://schemas.microsoft.com/office/drawing/2014/main" id="{F1ACCE8C-1363-458E-8D17-24AB3CFF0F15}"/>
               </a:ext>
             </a:extLst>
           </p:cNvPr>
@@ -11484,7 +11484,7 @@
           <p:cNvPr id="15" name="">
             <a:extLst xmlns:a="http://schemas.openxmlformats.org/drawingml/2006/main">
               <a:ext uri="{FF2B5EF4-FFF2-40B4-BE49-F238E27FC236}">
-                <a16:creationId xmlns:a16="http://schemas.microsoft.com/office/drawing/2014/main" id="{529C3342-A2F5-41E4-AC1A-5AC8335DD131}"/>
+                <a16:creationId xmlns:a16="http://schemas.microsoft.com/office/drawing/2014/main" id="{A90BB27F-9344-44E0-87FC-2719012A47A9}"/>
               </a:ext>
             </a:extLst>
           </p:cNvPr>
@@ -11542,7 +11542,7 @@
           <p:cNvPr id="16" name="">
             <a:extLst xmlns:a="http://schemas.openxmlformats.org/drawingml/2006/main">
               <a:ext uri="{FF2B5EF4-FFF2-40B4-BE49-F238E27FC236}">
-                <a16:creationId xmlns:a16="http://schemas.microsoft.com/office/drawing/2014/main" id="{3945ED73-05A8-439E-BE8B-E5867E4F6460}"/>
+                <a16:creationId xmlns:a16="http://schemas.microsoft.com/office/drawing/2014/main" id="{6CA410B4-EAA6-4F6D-8190-D351DDE26DF1}"/>
               </a:ext>
             </a:extLst>
           </p:cNvPr>
@@ -11600,7 +11600,7 @@
           <p:cNvPr id="17" name="">
             <a:extLst xmlns:a="http://schemas.openxmlformats.org/drawingml/2006/main">
               <a:ext uri="{FF2B5EF4-FFF2-40B4-BE49-F238E27FC236}">
-                <a16:creationId xmlns:a16="http://schemas.microsoft.com/office/drawing/2014/main" id="{E5D42A9B-9ED3-4673-A696-FCB24DCFED79}"/>
+                <a16:creationId xmlns:a16="http://schemas.microsoft.com/office/drawing/2014/main" id="{884B992D-254C-4195-ACE7-5898917E7A77}"/>
               </a:ext>
             </a:extLst>
           </p:cNvPr>
@@ -11631,7 +11631,7 @@
           <p:cNvPr id="18" name="">
             <a:extLst xmlns:a="http://schemas.openxmlformats.org/drawingml/2006/main">
               <a:ext uri="{FF2B5EF4-FFF2-40B4-BE49-F238E27FC236}">
-                <a16:creationId xmlns:a16="http://schemas.microsoft.com/office/drawing/2014/main" id="{C40625B1-BD73-4F8F-BEFA-8B1DC87B3A2C}"/>
+                <a16:creationId xmlns:a16="http://schemas.microsoft.com/office/drawing/2014/main" id="{44CC28AB-CC7A-401C-8689-57F58B1C0FF9}"/>
               </a:ext>
             </a:extLst>
           </p:cNvPr>
@@ -11687,7 +11687,7 @@
     </p:spTree>
     <p:extLst>
       <p:ext uri="{BB962C8B-B14F-4D97-AF65-F5344CB8AC3E}">
-        <p14:creationId xmlns:p14="http://schemas.microsoft.com/office/powerpoint/2010/main" val="1650317459"/>
+        <p14:creationId xmlns:p14="http://schemas.microsoft.com/office/powerpoint/2010/main" val="157461192"/>
       </p:ext>
     </p:extLst>
   </p:cSld>
@@ -11718,7 +11718,7 @@
           <p:cNvPr id="19" name="">
             <a:extLst xmlns:a="http://schemas.openxmlformats.org/drawingml/2006/main">
               <a:ext uri="{FF2B5EF4-FFF2-40B4-BE49-F238E27FC236}">
-                <a16:creationId xmlns:a16="http://schemas.microsoft.com/office/drawing/2014/main" id="{A76F2357-552F-471A-A673-B287F7F7AE05}"/>
+                <a16:creationId xmlns:a16="http://schemas.microsoft.com/office/drawing/2014/main" id="{75C85524-7447-4EBF-8D26-9633122A58E9}"/>
               </a:ext>
             </a:extLst>
           </p:cNvPr>
@@ -11776,7 +11776,7 @@
           <p:cNvPr id="2" name="">
             <a:extLst xmlns:a="http://schemas.openxmlformats.org/drawingml/2006/main">
               <a:ext uri="{FF2B5EF4-FFF2-40B4-BE49-F238E27FC236}">
-                <a16:creationId xmlns:a16="http://schemas.microsoft.com/office/drawing/2014/main" id="{1D4C6894-5ED2-4822-B785-0215E4B4A8C3}"/>
+                <a16:creationId xmlns:a16="http://schemas.microsoft.com/office/drawing/2014/main" id="{7EA20312-C985-4B15-9EE3-4D606172B6EC}"/>
               </a:ext>
             </a:extLst>
           </p:cNvPr>
@@ -11834,7 +11834,7 @@
           <p:cNvPr id="3" name="">
             <a:extLst xmlns:a="http://schemas.openxmlformats.org/drawingml/2006/main">
               <a:ext uri="{FF2B5EF4-FFF2-40B4-BE49-F238E27FC236}">
-                <a16:creationId xmlns:a16="http://schemas.microsoft.com/office/drawing/2014/main" id="{60AC062D-F540-45F3-B48C-F22D54343A76}"/>
+                <a16:creationId xmlns:a16="http://schemas.microsoft.com/office/drawing/2014/main" id="{AEB2BB4A-2EC2-4A8D-ADBC-08C49905A663}"/>
               </a:ext>
             </a:extLst>
           </p:cNvPr>
@@ -11865,7 +11865,7 @@
           <p:cNvPr id="4" name="">
             <a:extLst xmlns:a="http://schemas.openxmlformats.org/drawingml/2006/main">
               <a:ext uri="{FF2B5EF4-FFF2-40B4-BE49-F238E27FC236}">
-                <a16:creationId xmlns:a16="http://schemas.microsoft.com/office/drawing/2014/main" id="{2928E67B-28B0-44AD-ACE4-76BA53E6AE70}"/>
+                <a16:creationId xmlns:a16="http://schemas.microsoft.com/office/drawing/2014/main" id="{EFE9D023-06E7-46C8-9B70-9F19167D7203}"/>
               </a:ext>
             </a:extLst>
           </p:cNvPr>
@@ -11923,7 +11923,7 @@
           <p:cNvPr id="5" name="">
             <a:extLst xmlns:a="http://schemas.openxmlformats.org/drawingml/2006/main">
               <a:ext uri="{FF2B5EF4-FFF2-40B4-BE49-F238E27FC236}">
-                <a16:creationId xmlns:a16="http://schemas.microsoft.com/office/drawing/2014/main" id="{BA8148FD-0CFD-4EB2-98FC-613EED5537D3}"/>
+                <a16:creationId xmlns:a16="http://schemas.microsoft.com/office/drawing/2014/main" id="{6D5F6797-D5F8-4B1B-93B3-2D23A1617D68}"/>
               </a:ext>
             </a:extLst>
           </p:cNvPr>
@@ -11981,7 +11981,7 @@
           <p:cNvPr id="6" name="">
             <a:extLst xmlns:a="http://schemas.openxmlformats.org/drawingml/2006/main">
               <a:ext uri="{FF2B5EF4-FFF2-40B4-BE49-F238E27FC236}">
-                <a16:creationId xmlns:a16="http://schemas.microsoft.com/office/drawing/2014/main" id="{69C6D1FD-775F-446B-BEE4-845AD456B78D}"/>
+                <a16:creationId xmlns:a16="http://schemas.microsoft.com/office/drawing/2014/main" id="{7EF04D48-6F26-429B-8924-B604A760483A}"/>
               </a:ext>
             </a:extLst>
           </p:cNvPr>
@@ -12012,7 +12012,7 @@
           <p:cNvPr id="7" name="">
             <a:extLst xmlns:a="http://schemas.openxmlformats.org/drawingml/2006/main">
               <a:ext uri="{FF2B5EF4-FFF2-40B4-BE49-F238E27FC236}">
-                <a16:creationId xmlns:a16="http://schemas.microsoft.com/office/drawing/2014/main" id="{A75693CA-8481-414A-941B-488280F77615}"/>
+                <a16:creationId xmlns:a16="http://schemas.microsoft.com/office/drawing/2014/main" id="{DC391A82-0AAE-4E82-BC7B-A104F9D595BD}"/>
               </a:ext>
             </a:extLst>
           </p:cNvPr>
@@ -12070,7 +12070,7 @@
           <p:cNvPr id="8" name="">
             <a:extLst xmlns:a="http://schemas.openxmlformats.org/drawingml/2006/main">
               <a:ext uri="{FF2B5EF4-FFF2-40B4-BE49-F238E27FC236}">
-                <a16:creationId xmlns:a16="http://schemas.microsoft.com/office/drawing/2014/main" id="{71FEC771-5098-43D3-854F-77DCB6D5DC43}"/>
+                <a16:creationId xmlns:a16="http://schemas.microsoft.com/office/drawing/2014/main" id="{59505C17-7F8C-4FC9-ABB4-557FD6DF5868}"/>
               </a:ext>
             </a:extLst>
           </p:cNvPr>
@@ -12128,7 +12128,7 @@
           <p:cNvPr id="9" name="">
             <a:extLst xmlns:a="http://schemas.openxmlformats.org/drawingml/2006/main">
               <a:ext uri="{FF2B5EF4-FFF2-40B4-BE49-F238E27FC236}">
-                <a16:creationId xmlns:a16="http://schemas.microsoft.com/office/drawing/2014/main" id="{D62775BA-1A3F-450C-9610-3C3349C13B1F}"/>
+                <a16:creationId xmlns:a16="http://schemas.microsoft.com/office/drawing/2014/main" id="{A8E952B7-F64F-4058-967D-02B482AA5F46}"/>
               </a:ext>
             </a:extLst>
           </p:cNvPr>
@@ -12159,7 +12159,7 @@
           <p:cNvPr id="10" name="">
             <a:extLst xmlns:a="http://schemas.openxmlformats.org/drawingml/2006/main">
               <a:ext uri="{FF2B5EF4-FFF2-40B4-BE49-F238E27FC236}">
-                <a16:creationId xmlns:a16="http://schemas.microsoft.com/office/drawing/2014/main" id="{E99FF3D3-F576-4E11-B50F-8DBD63661463}"/>
+                <a16:creationId xmlns:a16="http://schemas.microsoft.com/office/drawing/2014/main" id="{0E8310E4-17FF-4371-BC95-86D8052FF04D}"/>
               </a:ext>
             </a:extLst>
           </p:cNvPr>
@@ -12217,7 +12217,7 @@
           <p:cNvPr id="11" name="">
             <a:extLst xmlns:a="http://schemas.openxmlformats.org/drawingml/2006/main">
               <a:ext uri="{FF2B5EF4-FFF2-40B4-BE49-F238E27FC236}">
-                <a16:creationId xmlns:a16="http://schemas.microsoft.com/office/drawing/2014/main" id="{C9C23A2F-53AD-4FB3-8E2C-219598F731E7}"/>
+                <a16:creationId xmlns:a16="http://schemas.microsoft.com/office/drawing/2014/main" id="{04BA3231-16C9-433C-87CE-49795863D94F}"/>
               </a:ext>
             </a:extLst>
           </p:cNvPr>
@@ -12275,7 +12275,7 @@
           <p:cNvPr id="12" name="">
             <a:extLst xmlns:a="http://schemas.openxmlformats.org/drawingml/2006/main">
               <a:ext uri="{FF2B5EF4-FFF2-40B4-BE49-F238E27FC236}">
-                <a16:creationId xmlns:a16="http://schemas.microsoft.com/office/drawing/2014/main" id="{1E7835E5-BD9D-4ECB-93A3-2D353190C55A}"/>
+                <a16:creationId xmlns:a16="http://schemas.microsoft.com/office/drawing/2014/main" id="{172F0CB7-DA44-4856-B02F-1BD802497B3D}"/>
               </a:ext>
             </a:extLst>
           </p:cNvPr>
@@ -12306,7 +12306,7 @@
           <p:cNvPr id="13" name="">
             <a:extLst xmlns:a="http://schemas.openxmlformats.org/drawingml/2006/main">
               <a:ext uri="{FF2B5EF4-FFF2-40B4-BE49-F238E27FC236}">
-                <a16:creationId xmlns:a16="http://schemas.microsoft.com/office/drawing/2014/main" id="{86F2034A-D546-4F6E-91CD-D192B3DEC1FC}"/>
+                <a16:creationId xmlns:a16="http://schemas.microsoft.com/office/drawing/2014/main" id="{C0161E49-EEE8-4D0E-9A60-7840EB1D1AA1}"/>
               </a:ext>
             </a:extLst>
           </p:cNvPr>
@@ -12364,7 +12364,7 @@
           <p:cNvPr id="14" name="">
             <a:extLst xmlns:a="http://schemas.openxmlformats.org/drawingml/2006/main">
               <a:ext uri="{FF2B5EF4-FFF2-40B4-BE49-F238E27FC236}">
-                <a16:creationId xmlns:a16="http://schemas.microsoft.com/office/drawing/2014/main" id="{7C3662ED-2145-4F87-8745-1F74489DA73F}"/>
+                <a16:creationId xmlns:a16="http://schemas.microsoft.com/office/drawing/2014/main" id="{711530D3-7C50-4E6F-A174-BCA349BAF52D}"/>
               </a:ext>
             </a:extLst>
           </p:cNvPr>
@@ -12412,7 +12412,7 @@
                 <a:ea typeface="Helvetica Neue"/>
                 <a:cs typeface="Helvetica Neue"/>
               </a:rPr>
-              <a:t>Observed semantics across Linux, macOS, Windows, CI, IDEs, and agent hosts.</a:t>
+              <a:t>A target for separately observed semantics across Linux, macOS, Windows, CI, IDEs, and agent hosts.</a:t>
             </a:r>
           </a:p>
         </p:txBody>
@@ -12422,7 +12422,7 @@
           <p:cNvPr id="15" name="">
             <a:extLst xmlns:a="http://schemas.openxmlformats.org/drawingml/2006/main">
               <a:ext uri="{FF2B5EF4-FFF2-40B4-BE49-F238E27FC236}">
-                <a16:creationId xmlns:a16="http://schemas.microsoft.com/office/drawing/2014/main" id="{7F838409-49FD-4AB4-9D5F-DF69B5A343D8}"/>
+                <a16:creationId xmlns:a16="http://schemas.microsoft.com/office/drawing/2014/main" id="{208E4612-45C2-44ED-97BF-B8F16F611B2D}"/>
               </a:ext>
             </a:extLst>
           </p:cNvPr>
@@ -12453,7 +12453,7 @@
           <p:cNvPr id="16" name="">
             <a:extLst xmlns:a="http://schemas.openxmlformats.org/drawingml/2006/main">
               <a:ext uri="{FF2B5EF4-FFF2-40B4-BE49-F238E27FC236}">
-                <a16:creationId xmlns:a16="http://schemas.microsoft.com/office/drawing/2014/main" id="{114E3D70-263D-4965-895A-77F23CA5962B}"/>
+                <a16:creationId xmlns:a16="http://schemas.microsoft.com/office/drawing/2014/main" id="{4AEDDB0A-FFEC-440A-8CD0-DC939A0C4049}"/>
               </a:ext>
             </a:extLst>
           </p:cNvPr>
@@ -12511,7 +12511,7 @@
           <p:cNvPr id="17" name="">
             <a:extLst xmlns:a="http://schemas.openxmlformats.org/drawingml/2006/main">
               <a:ext uri="{FF2B5EF4-FFF2-40B4-BE49-F238E27FC236}">
-                <a16:creationId xmlns:a16="http://schemas.microsoft.com/office/drawing/2014/main" id="{1E80267E-F576-4EE2-A0D4-B1A3CB8C18D8}"/>
+                <a16:creationId xmlns:a16="http://schemas.microsoft.com/office/drawing/2014/main" id="{8BE10988-EA4F-40D5-9468-BC556563E1C5}"/>
               </a:ext>
             </a:extLst>
           </p:cNvPr>
@@ -12569,7 +12569,7 @@
           <p:cNvPr id="18" name="">
             <a:extLst xmlns:a="http://schemas.openxmlformats.org/drawingml/2006/main">
               <a:ext uri="{FF2B5EF4-FFF2-40B4-BE49-F238E27FC236}">
-                <a16:creationId xmlns:a16="http://schemas.microsoft.com/office/drawing/2014/main" id="{C4A0E106-ABC2-4D17-990C-799DA1E9CC15}"/>
+                <a16:creationId xmlns:a16="http://schemas.microsoft.com/office/drawing/2014/main" id="{E79C2CC8-20CC-4619-9272-BA82E91D3E5C}"/>
               </a:ext>
             </a:extLst>
           </p:cNvPr>
@@ -12625,7 +12625,7 @@
     </p:spTree>
     <p:extLst>
       <p:ext uri="{BB962C8B-B14F-4D97-AF65-F5344CB8AC3E}">
-        <p14:creationId xmlns:p14="http://schemas.microsoft.com/office/powerpoint/2010/main" val="398088920"/>
+        <p14:creationId xmlns:p14="http://schemas.microsoft.com/office/powerpoint/2010/main" val="1682170563"/>
       </p:ext>
     </p:extLst>
   </p:cSld>
@@ -12656,7 +12656,7 @@
           <p:cNvPr id="19" name="">
             <a:extLst xmlns:a="http://schemas.openxmlformats.org/drawingml/2006/main">
               <a:ext uri="{FF2B5EF4-FFF2-40B4-BE49-F238E27FC236}">
-                <a16:creationId xmlns:a16="http://schemas.microsoft.com/office/drawing/2014/main" id="{3BAC6480-EE05-4198-BE10-F3BA8F9DA3AD}"/>
+                <a16:creationId xmlns:a16="http://schemas.microsoft.com/office/drawing/2014/main" id="{0CFA0EE3-D03B-432C-ACB7-9D82A0CC8B28}"/>
               </a:ext>
             </a:extLst>
           </p:cNvPr>
@@ -12714,7 +12714,7 @@
           <p:cNvPr id="2" name="">
             <a:extLst xmlns:a="http://schemas.openxmlformats.org/drawingml/2006/main">
               <a:ext uri="{FF2B5EF4-FFF2-40B4-BE49-F238E27FC236}">
-                <a16:creationId xmlns:a16="http://schemas.microsoft.com/office/drawing/2014/main" id="{8401D8DB-FAB7-45FA-B56A-48DE3A7223D9}"/>
+                <a16:creationId xmlns:a16="http://schemas.microsoft.com/office/drawing/2014/main" id="{580B6053-12F1-4AF9-A31B-DBA4A4D364FC}"/>
               </a:ext>
             </a:extLst>
           </p:cNvPr>
@@ -12772,7 +12772,7 @@
           <p:cNvPr id="3" name="">
             <a:extLst xmlns:a="http://schemas.openxmlformats.org/drawingml/2006/main">
               <a:ext uri="{FF2B5EF4-FFF2-40B4-BE49-F238E27FC236}">
-                <a16:creationId xmlns:a16="http://schemas.microsoft.com/office/drawing/2014/main" id="{1C2BC212-A2B7-424A-AA90-97542941DBF5}"/>
+                <a16:creationId xmlns:a16="http://schemas.microsoft.com/office/drawing/2014/main" id="{0A3ACA87-694D-4624-8079-B5976CA83790}"/>
               </a:ext>
             </a:extLst>
           </p:cNvPr>
@@ -12803,7 +12803,7 @@
           <p:cNvPr id="4" name="">
             <a:extLst xmlns:a="http://schemas.openxmlformats.org/drawingml/2006/main">
               <a:ext uri="{FF2B5EF4-FFF2-40B4-BE49-F238E27FC236}">
-                <a16:creationId xmlns:a16="http://schemas.microsoft.com/office/drawing/2014/main" id="{D6F1FE6D-2570-4250-91C1-7F35E18E0628}"/>
+                <a16:creationId xmlns:a16="http://schemas.microsoft.com/office/drawing/2014/main" id="{15701EA3-808D-4FDB-A659-5501A9689875}"/>
               </a:ext>
             </a:extLst>
           </p:cNvPr>
@@ -12861,7 +12861,7 @@
           <p:cNvPr id="5" name="">
             <a:extLst xmlns:a="http://schemas.openxmlformats.org/drawingml/2006/main">
               <a:ext uri="{FF2B5EF4-FFF2-40B4-BE49-F238E27FC236}">
-                <a16:creationId xmlns:a16="http://schemas.microsoft.com/office/drawing/2014/main" id="{655A0401-1CEC-4D7E-9281-D5E7BBE857B9}"/>
+                <a16:creationId xmlns:a16="http://schemas.microsoft.com/office/drawing/2014/main" id="{063317F2-2F00-4C21-AC9D-A030F0D0D62A}"/>
               </a:ext>
             </a:extLst>
           </p:cNvPr>
@@ -12919,7 +12919,7 @@
           <p:cNvPr id="6" name="">
             <a:extLst xmlns:a="http://schemas.openxmlformats.org/drawingml/2006/main">
               <a:ext uri="{FF2B5EF4-FFF2-40B4-BE49-F238E27FC236}">
-                <a16:creationId xmlns:a16="http://schemas.microsoft.com/office/drawing/2014/main" id="{53C360F5-8557-4CA0-AE92-97BDB52C8D42}"/>
+                <a16:creationId xmlns:a16="http://schemas.microsoft.com/office/drawing/2014/main" id="{757A7D8C-2A0F-43D7-858B-C26EDB3C44F4}"/>
               </a:ext>
             </a:extLst>
           </p:cNvPr>
@@ -12950,7 +12950,7 @@
           <p:cNvPr id="7" name="">
             <a:extLst xmlns:a="http://schemas.openxmlformats.org/drawingml/2006/main">
               <a:ext uri="{FF2B5EF4-FFF2-40B4-BE49-F238E27FC236}">
-                <a16:creationId xmlns:a16="http://schemas.microsoft.com/office/drawing/2014/main" id="{D2E1F051-B80B-47A9-9851-B944E698D037}"/>
+                <a16:creationId xmlns:a16="http://schemas.microsoft.com/office/drawing/2014/main" id="{2D59AC07-2050-4691-9930-9C5AEBE3844A}"/>
               </a:ext>
             </a:extLst>
           </p:cNvPr>
@@ -13008,7 +13008,7 @@
           <p:cNvPr id="8" name="">
             <a:extLst xmlns:a="http://schemas.openxmlformats.org/drawingml/2006/main">
               <a:ext uri="{FF2B5EF4-FFF2-40B4-BE49-F238E27FC236}">
-                <a16:creationId xmlns:a16="http://schemas.microsoft.com/office/drawing/2014/main" id="{AC55E6BC-5578-462C-89DA-C60A18C92D63}"/>
+                <a16:creationId xmlns:a16="http://schemas.microsoft.com/office/drawing/2014/main" id="{C6DC1E04-C0F1-402B-AEF1-DA1B4EB974D0}"/>
               </a:ext>
             </a:extLst>
           </p:cNvPr>
@@ -13066,7 +13066,7 @@
           <p:cNvPr id="9" name="">
             <a:extLst xmlns:a="http://schemas.openxmlformats.org/drawingml/2006/main">
               <a:ext uri="{FF2B5EF4-FFF2-40B4-BE49-F238E27FC236}">
-                <a16:creationId xmlns:a16="http://schemas.microsoft.com/office/drawing/2014/main" id="{8CBF8DAB-1EBC-43BE-A526-1BA142202980}"/>
+                <a16:creationId xmlns:a16="http://schemas.microsoft.com/office/drawing/2014/main" id="{74AF6D94-DD9F-4159-9E96-8218615A4965}"/>
               </a:ext>
             </a:extLst>
           </p:cNvPr>
@@ -13170,7 +13170,7 @@
           <p:cNvPr id="10" name="">
             <a:extLst xmlns:a="http://schemas.openxmlformats.org/drawingml/2006/main">
               <a:ext uri="{FF2B5EF4-FFF2-40B4-BE49-F238E27FC236}">
-                <a16:creationId xmlns:a16="http://schemas.microsoft.com/office/drawing/2014/main" id="{CFB555B6-DCF9-400D-8913-26DFC178FF77}"/>
+                <a16:creationId xmlns:a16="http://schemas.microsoft.com/office/drawing/2014/main" id="{33E8FA01-A3E5-427B-A25D-24466EABE892}"/>
               </a:ext>
             </a:extLst>
           </p:cNvPr>
@@ -13201,7 +13201,7 @@
           <p:cNvPr id="11" name="">
             <a:extLst xmlns:a="http://schemas.openxmlformats.org/drawingml/2006/main">
               <a:ext uri="{FF2B5EF4-FFF2-40B4-BE49-F238E27FC236}">
-                <a16:creationId xmlns:a16="http://schemas.microsoft.com/office/drawing/2014/main" id="{F7A5813B-53CA-4A35-B159-999038A459B8}"/>
+                <a16:creationId xmlns:a16="http://schemas.microsoft.com/office/drawing/2014/main" id="{329DC3CA-09C3-4B44-B73C-6CD1CDCB416D}"/>
               </a:ext>
             </a:extLst>
           </p:cNvPr>
@@ -13259,7 +13259,7 @@
           <p:cNvPr id="12" name="">
             <a:extLst xmlns:a="http://schemas.openxmlformats.org/drawingml/2006/main">
               <a:ext uri="{FF2B5EF4-FFF2-40B4-BE49-F238E27FC236}">
-                <a16:creationId xmlns:a16="http://schemas.microsoft.com/office/drawing/2014/main" id="{38F43DE8-0E9A-4CCB-B576-331F0FB53681}"/>
+                <a16:creationId xmlns:a16="http://schemas.microsoft.com/office/drawing/2014/main" id="{0DA8D4AD-5A3E-4798-8CD8-388996C5CCC1}"/>
               </a:ext>
             </a:extLst>
           </p:cNvPr>
@@ -13317,7 +13317,7 @@
           <p:cNvPr id="13" name="">
             <a:extLst xmlns:a="http://schemas.openxmlformats.org/drawingml/2006/main">
               <a:ext uri="{FF2B5EF4-FFF2-40B4-BE49-F238E27FC236}">
-                <a16:creationId xmlns:a16="http://schemas.microsoft.com/office/drawing/2014/main" id="{B8AA2887-7964-4E82-892B-0C0F5564EB9B}"/>
+                <a16:creationId xmlns:a16="http://schemas.microsoft.com/office/drawing/2014/main" id="{3E934AB5-9480-40C0-810A-4E9CD065C611}"/>
               </a:ext>
             </a:extLst>
           </p:cNvPr>
@@ -13421,7 +13421,7 @@
           <p:cNvPr id="14" name="">
             <a:extLst xmlns:a="http://schemas.openxmlformats.org/drawingml/2006/main">
               <a:ext uri="{FF2B5EF4-FFF2-40B4-BE49-F238E27FC236}">
-                <a16:creationId xmlns:a16="http://schemas.microsoft.com/office/drawing/2014/main" id="{CB10D1A0-2701-4979-8858-4C9C91DA5EF5}"/>
+                <a16:creationId xmlns:a16="http://schemas.microsoft.com/office/drawing/2014/main" id="{84E3EB60-6220-4142-AD97-0E277AF3F23D}"/>
               </a:ext>
             </a:extLst>
           </p:cNvPr>
@@ -13452,7 +13452,7 @@
           <p:cNvPr id="15" name="">
             <a:extLst xmlns:a="http://schemas.openxmlformats.org/drawingml/2006/main">
               <a:ext uri="{FF2B5EF4-FFF2-40B4-BE49-F238E27FC236}">
-                <a16:creationId xmlns:a16="http://schemas.microsoft.com/office/drawing/2014/main" id="{6C2898DB-DE18-4845-AC1D-BBE105B6ACD2}"/>
+                <a16:creationId xmlns:a16="http://schemas.microsoft.com/office/drawing/2014/main" id="{5A36B7E1-82A7-48BA-B8A3-AD074D7E9E61}"/>
               </a:ext>
             </a:extLst>
           </p:cNvPr>
@@ -13510,7 +13510,7 @@
           <p:cNvPr id="16" name="">
             <a:extLst xmlns:a="http://schemas.openxmlformats.org/drawingml/2006/main">
               <a:ext uri="{FF2B5EF4-FFF2-40B4-BE49-F238E27FC236}">
-                <a16:creationId xmlns:a16="http://schemas.microsoft.com/office/drawing/2014/main" id="{6A69430C-FCDC-458A-A311-A9301361AAF6}"/>
+                <a16:creationId xmlns:a16="http://schemas.microsoft.com/office/drawing/2014/main" id="{3A4581E7-C0CB-413A-B550-43F12B153273}"/>
               </a:ext>
             </a:extLst>
           </p:cNvPr>
@@ -13568,7 +13568,7 @@
           <p:cNvPr id="17" name="">
             <a:extLst xmlns:a="http://schemas.openxmlformats.org/drawingml/2006/main">
               <a:ext uri="{FF2B5EF4-FFF2-40B4-BE49-F238E27FC236}">
-                <a16:creationId xmlns:a16="http://schemas.microsoft.com/office/drawing/2014/main" id="{09885112-8451-43AC-8058-D70B35B52D2D}"/>
+                <a16:creationId xmlns:a16="http://schemas.microsoft.com/office/drawing/2014/main" id="{EF5B5650-5535-4994-84E4-B24CB0055FC2}"/>
               </a:ext>
             </a:extLst>
           </p:cNvPr>
@@ -13672,7 +13672,7 @@
           <p:cNvPr id="18" name="">
             <a:extLst xmlns:a="http://schemas.openxmlformats.org/drawingml/2006/main">
               <a:ext uri="{FF2B5EF4-FFF2-40B4-BE49-F238E27FC236}">
-                <a16:creationId xmlns:a16="http://schemas.microsoft.com/office/drawing/2014/main" id="{7CA787D7-EDAD-4228-9045-C431E2E26414}"/>
+                <a16:creationId xmlns:a16="http://schemas.microsoft.com/office/drawing/2014/main" id="{4BB010B4-44CB-4EC7-92E6-9388819FDDE2}"/>
               </a:ext>
             </a:extLst>
           </p:cNvPr>
@@ -13728,7 +13728,7 @@
     </p:spTree>
     <p:extLst>
       <p:ext uri="{BB962C8B-B14F-4D97-AF65-F5344CB8AC3E}">
-        <p14:creationId xmlns:p14="http://schemas.microsoft.com/office/powerpoint/2010/main" val="81434338"/>
+        <p14:creationId xmlns:p14="http://schemas.microsoft.com/office/powerpoint/2010/main" val="1773879048"/>
       </p:ext>
     </p:extLst>
   </p:cSld>

</xml_diff>